<commit_message>
Update presentation deck with final visual polish fixes
Stat callout SLA label updated to 99.9%, adaptive font sizing for
longer stat values, and increased bullet spacing on summary slide.
</commit_message>
<xml_diff>
--- a/deliverables/JHBI_Unified_Payments_Platform.pptx
+++ b/deliverables/JHBI_Unified_Payments_Platform.pptx
@@ -4,6 +4,9 @@
   <p:sldMasterIdLst>
     <p:sldMasterId id="2147483648" r:id="rId1"/>
   </p:sldMasterIdLst>
+  <p:notesMasterIdLst>
+    <p:notesMasterId r:id="rId9"/>
+  </p:notesMasterIdLst>
   <p:sldIdLst>
     <p:sldId id="256" r:id="rId2"/>
     <p:sldId id="257" r:id="rId3"/>
@@ -13,10 +16,7 @@
     <p:sldId id="261" r:id="rId7"/>
     <p:sldId id="262" r:id="rId8"/>
   </p:sldIdLst>
-  <p:notesMasterIdLst>
-    <p:notesMasterId r:id="rId9"/>
-  </p:notesMasterIdLst>
-  <p:sldSz cx="9144000" cy="5143500"/>
+  <p:sldSz cx="9144000" cy="5143500" type="screen16x9"/>
   <p:notesSz cx="5143500" cy="9144000"/>
   <p:defaultTextStyle>
     <a:lvl1pPr marL="0" algn="l" defTabSz="914400" rtl="0" eaLnBrk="1" latinLnBrk="0" hangingPunct="1">
@@ -110,6 +110,11 @@
       </a:defRPr>
     </a:lvl9pPr>
   </p:defaultTextStyle>
+  <p:extLst>
+    <p:ext uri="{EFAFB233-063F-42B5-8137-9DF3F51BA10A}">
+      <p15:sldGuideLst xmlns:p15="http://schemas.microsoft.com/office/powerpoint/2012/main"/>
+    </p:ext>
+  </p:extLst>
 </p:presentation>
 </file>
 
@@ -135,234 +140,10 @@
           <a:chExt cx="0" cy="0"/>
         </a:xfrm>
       </p:grpSpPr>
-      <p:sp>
-        <p:nvSpPr>
-          <p:cNvPr id="2" name="Header Placeholder 1"/>
-          <p:cNvSpPr>
-            <a:spLocks noGrp="1"/>
-          </p:cNvSpPr>
-          <p:nvPr>
-            <p:ph type="hdr" sz="quarter"/>
-          </p:nvPr>
-        </p:nvSpPr>
-        <p:spPr>
-          <a:xfrm>
-            <a:off x="0" y="0"/>
-            <a:ext cx="2971800" cy="458788"/>
-          </a:xfrm>
-          <a:prstGeom prst="rect">
-            <a:avLst/>
-          </a:prstGeom>
-        </p:spPr>
-        <p:txBody>
-          <a:bodyPr vert="horz" lIns="91440" tIns="45720" rIns="91440" bIns="45720" rtlCol="0"/>
-          <a:lstStyle>
-            <a:lvl1pPr algn="l">
-              <a:defRPr sz="1200"/>
-            </a:lvl1pPr>
-          </a:lstStyle>
-          <a:p>
-            <a:endParaRPr lang="en-US"/>
-          </a:p>
-        </p:txBody>
-      </p:sp>
-      <p:sp>
-        <p:nvSpPr>
-          <p:cNvPr id="3" name="Date Placeholder 2"/>
-          <p:cNvSpPr>
-            <a:spLocks noGrp="1"/>
-          </p:cNvSpPr>
-          <p:nvPr>
-            <p:ph type="dt" idx="1"/>
-          </p:nvPr>
-        </p:nvSpPr>
-        <p:spPr>
-          <a:xfrm>
-            <a:off x="3884613" y="0"/>
-            <a:ext cx="2971800" cy="458788"/>
-          </a:xfrm>
-          <a:prstGeom prst="rect">
-            <a:avLst/>
-          </a:prstGeom>
-        </p:spPr>
-        <p:txBody>
-          <a:bodyPr vert="horz" lIns="91440" tIns="45720" rIns="91440" bIns="45720" rtlCol="0"/>
-          <a:lstStyle>
-            <a:lvl1pPr algn="r">
-              <a:defRPr sz="1200"/>
-            </a:lvl1pPr>
-          </a:lstStyle>
-          <a:p>
-            <a:fld id="{5282F153-3F37-0F45-9E97-73ACFA13230C}" type="datetimeFigureOut">
-              <a:rPr lang="en-US"/>
-              <a:t>7/23/19</a:t>
-            </a:fld>
-            <a:endParaRPr lang="en-US"/>
-          </a:p>
-        </p:txBody>
-      </p:sp>
-      <p:sp>
-        <p:nvSpPr>
-          <p:cNvPr id="4" name="Slide Image Placeholder 3"/>
-          <p:cNvSpPr>
-            <a:spLocks noGrp="1" noRot="1" noChangeAspect="1"/>
-          </p:cNvSpPr>
-          <p:nvPr>
-            <p:ph type="sldImg" idx="2"/>
-          </p:nvPr>
-        </p:nvSpPr>
-        <p:spPr>
-          <a:xfrm>
-            <a:off x="685800" y="1143000"/>
-            <a:ext cx="5486400" cy="3086100"/>
-          </a:xfrm>
-          <a:prstGeom prst="rect">
-            <a:avLst/>
-          </a:prstGeom>
-          <a:noFill/>
-          <a:ln w="12700">
-            <a:solidFill>
-              <a:prstClr val="black"/>
-            </a:solidFill>
-          </a:ln>
-        </p:spPr>
-        <p:txBody>
-          <a:bodyPr vert="horz" lIns="91440" tIns="45720" rIns="91440" bIns="45720" rtlCol="0" anchor="ctr"/>
-          <a:lstStyle/>
-          <a:p>
-            <a:endParaRPr lang="en-US"/>
-          </a:p>
-        </p:txBody>
-      </p:sp>
-      <p:sp>
-        <p:nvSpPr>
-          <p:cNvPr id="5" name="Notes Placeholder 4"/>
-          <p:cNvSpPr>
-            <a:spLocks noGrp="1"/>
-          </p:cNvSpPr>
-          <p:nvPr>
-            <p:ph type="body" sz="quarter" idx="3"/>
-          </p:nvPr>
-        </p:nvSpPr>
-        <p:spPr>
-          <a:xfrm>
-            <a:off x="685800" y="4400550"/>
-            <a:ext cx="5486400" cy="3600450"/>
-          </a:xfrm>
-          <a:prstGeom prst="rect">
-            <a:avLst/>
-          </a:prstGeom>
-        </p:spPr>
-        <p:txBody>
-          <a:bodyPr vert="horz" lIns="91440" tIns="45720" rIns="91440" bIns="45720" rtlCol="0"/>
-          <a:lstStyle/>
-          <a:p>
-            <a:pPr lvl="0"/>
-            <a:r>
-              <a:rPr lang="en-US"/>
-              <a:t>Click to edit Master text styles</a:t>
-            </a:r>
-          </a:p>
-          <a:p>
-            <a:pPr lvl="1"/>
-            <a:r>
-              <a:rPr lang="en-US"/>
-              <a:t>Second level</a:t>
-            </a:r>
-          </a:p>
-          <a:p>
-            <a:pPr lvl="2"/>
-            <a:r>
-              <a:rPr lang="en-US"/>
-              <a:t>Third level</a:t>
-            </a:r>
-          </a:p>
-          <a:p>
-            <a:pPr lvl="3"/>
-            <a:r>
-              <a:rPr lang="en-US"/>
-              <a:t>Fourth level</a:t>
-            </a:r>
-          </a:p>
-          <a:p>
-            <a:pPr lvl="4"/>
-            <a:r>
-              <a:rPr lang="en-US"/>
-              <a:t>Fifth level</a:t>
-            </a:r>
-          </a:p>
-        </p:txBody>
-      </p:sp>
-      <p:sp>
-        <p:nvSpPr>
-          <p:cNvPr id="6" name="Footer Placeholder 5"/>
-          <p:cNvSpPr>
-            <a:spLocks noGrp="1"/>
-          </p:cNvSpPr>
-          <p:nvPr>
-            <p:ph type="ftr" sz="quarter" idx="4"/>
-          </p:nvPr>
-        </p:nvSpPr>
-        <p:spPr>
-          <a:xfrm>
-            <a:off x="0" y="8685213"/>
-            <a:ext cx="2971800" cy="458787"/>
-          </a:xfrm>
-          <a:prstGeom prst="rect">
-            <a:avLst/>
-          </a:prstGeom>
-        </p:spPr>
-        <p:txBody>
-          <a:bodyPr vert="horz" lIns="91440" tIns="45720" rIns="91440" bIns="45720" rtlCol="0" anchor="b"/>
-          <a:lstStyle>
-            <a:lvl1pPr algn="l">
-              <a:defRPr sz="1200"/>
-            </a:lvl1pPr>
-          </a:lstStyle>
-          <a:p>
-            <a:endParaRPr lang="en-US"/>
-          </a:p>
-        </p:txBody>
-      </p:sp>
-      <p:sp>
-        <p:nvSpPr>
-          <p:cNvPr id="7" name="Slide Number Placeholder 6"/>
-          <p:cNvSpPr>
-            <a:spLocks noGrp="1"/>
-          </p:cNvSpPr>
-          <p:nvPr>
-            <p:ph type="sldNum" sz="quarter" idx="5"/>
-          </p:nvPr>
-        </p:nvSpPr>
-        <p:spPr>
-          <a:xfrm>
-            <a:off x="3884613" y="8685213"/>
-            <a:ext cx="2971800" cy="458787"/>
-          </a:xfrm>
-          <a:prstGeom prst="rect">
-            <a:avLst/>
-          </a:prstGeom>
-        </p:spPr>
-        <p:txBody>
-          <a:bodyPr vert="horz" lIns="91440" tIns="45720" rIns="91440" bIns="45720" rtlCol="0" anchor="b"/>
-          <a:lstStyle>
-            <a:lvl1pPr algn="r">
-              <a:defRPr sz="1200"/>
-            </a:lvl1pPr>
-          </a:lstStyle>
-          <a:p>
-            <a:fld id="{CE5E9CC1-C706-0F49-92D6-E571CC5EEA8F}" type="slidenum">
-              <a:rPr lang="en-US"/>
-              <a:t>‹#›</a:t>
-            </a:fld>
-            <a:endParaRPr lang="en-US"/>
-          </a:p>
-        </p:txBody>
-      </p:sp>
     </p:spTree>
     <p:extLst>
       <p:ext uri="{BB962C8B-B14F-4D97-AF65-F5344CB8AC3E}">
-        <p14:creationId xmlns:p14="http://schemas.microsoft.com/office/powerpoint/2010/main" val="1024086991"/>
+        <p14:creationId xmlns:p14="http://schemas.microsoft.com/office/powerpoint/2010/main" val="1796737285"/>
       </p:ext>
     </p:extLst>
   </p:cSld>
@@ -506,10 +287,6 @@
           <a:bodyPr/>
           <a:lstStyle/>
           <a:p>
-            <a:r>
-              <a:rPr lang="en-US" dirty="0"/>
-              <a:t/>
-            </a:r>
             <a:endParaRPr lang="en-US" dirty="0"/>
           </a:p>
         </p:txBody>
@@ -594,10 +371,6 @@
           <a:bodyPr/>
           <a:lstStyle/>
           <a:p>
-            <a:r>
-              <a:rPr lang="en-US" dirty="0"/>
-              <a:t/>
-            </a:r>
             <a:endParaRPr lang="en-US" dirty="0"/>
           </a:p>
         </p:txBody>
@@ -682,10 +455,6 @@
           <a:bodyPr/>
           <a:lstStyle/>
           <a:p>
-            <a:r>
-              <a:rPr lang="en-US" dirty="0"/>
-              <a:t/>
-            </a:r>
             <a:endParaRPr lang="en-US" dirty="0"/>
           </a:p>
         </p:txBody>
@@ -770,10 +539,6 @@
           <a:bodyPr/>
           <a:lstStyle/>
           <a:p>
-            <a:r>
-              <a:rPr lang="en-US" dirty="0"/>
-              <a:t/>
-            </a:r>
             <a:endParaRPr lang="en-US" dirty="0"/>
           </a:p>
         </p:txBody>
@@ -858,10 +623,6 @@
           <a:bodyPr/>
           <a:lstStyle/>
           <a:p>
-            <a:r>
-              <a:rPr lang="en-US" dirty="0"/>
-              <a:t/>
-            </a:r>
             <a:endParaRPr lang="en-US" dirty="0"/>
           </a:p>
         </p:txBody>
@@ -946,10 +707,6 @@
           <a:bodyPr/>
           <a:lstStyle/>
           <a:p>
-            <a:r>
-              <a:rPr lang="en-US" dirty="0"/>
-              <a:t/>
-            </a:r>
             <a:endParaRPr lang="en-US" dirty="0"/>
           </a:p>
         </p:txBody>
@@ -1034,10 +791,6 @@
           <a:bodyPr/>
           <a:lstStyle/>
           <a:p>
-            <a:r>
-              <a:rPr lang="en-US" dirty="0"/>
-              <a:t/>
-            </a:r>
             <a:endParaRPr lang="en-US" dirty="0"/>
           </a:p>
         </p:txBody>
@@ -1111,6 +864,11 @@
 <file path=ppt/slideMasters/slideMaster1.xml><?xml version="1.0" encoding="utf-8"?>
 <p:sldMaster xmlns:a="http://schemas.openxmlformats.org/drawingml/2006/main" xmlns:r="http://schemas.openxmlformats.org/officeDocument/2006/relationships" xmlns:p="http://schemas.openxmlformats.org/presentationml/2006/main">
   <p:cSld>
+    <p:bg>
+      <p:bgRef idx="1001">
+        <a:schemeClr val="bg1"/>
+      </p:bgRef>
+    </p:bg>
     <p:spTree>
       <p:nvGrpSpPr>
         <p:cNvPr id="1" name=""/>
@@ -1393,6 +1151,7 @@
         <a:solidFill>
           <a:srgbClr val="0A2342"/>
         </a:solidFill>
+        <a:effectLst/>
       </p:bgPr>
     </p:bg>
     <p:spTree>
@@ -1430,6 +1189,13 @@
           </a:solidFill>
           <a:ln/>
         </p:spPr>
+        <p:txBody>
+          <a:bodyPr/>
+          <a:lstStyle/>
+          <a:p>
+            <a:endParaRPr lang="en-US"/>
+          </a:p>
+        </p:txBody>
       </p:sp>
       <p:sp>
         <p:nvSpPr>
@@ -1452,6 +1218,13 @@
           </a:solidFill>
           <a:ln/>
         </p:spPr>
+        <p:txBody>
+          <a:bodyPr/>
+          <a:lstStyle/>
+          <a:p>
+            <a:endParaRPr lang="en-US"/>
+          </a:p>
+        </p:txBody>
       </p:sp>
       <p:sp>
         <p:nvSpPr>
@@ -1474,62 +1247,17 @@
           </a:solidFill>
           <a:ln/>
         </p:spPr>
+        <p:txBody>
+          <a:bodyPr/>
+          <a:lstStyle/>
+          <a:p>
+            <a:endParaRPr lang="en-US"/>
+          </a:p>
+        </p:txBody>
       </p:sp>
       <p:pic>
         <p:nvPicPr>
-          <p:cNvPr id="5" name="Image 0" descr="preencoded.png">    </p:cNvPr>
-          <p:cNvPicPr>
-            <a:picLocks noChangeAspect="1"/>
-          </p:cNvPicPr>
-          <p:nvPr/>
-        </p:nvPicPr>
-        <p:blipFill>
-          <a:blip r:embed="rId1">
-            <a:alphaModFix amt="40000"/>
-          </a:blip>
-          <a:stretch>
-            <a:fillRect/>
-          </a:stretch>
-        </p:blipFill>
-        <p:spPr>
-          <a:xfrm>
-            <a:off x="6949440" y="640080"/>
-            <a:ext cx="640080" cy="640080"/>
-          </a:xfrm>
-          <a:prstGeom prst="rect">
-            <a:avLst/>
-          </a:prstGeom>
-        </p:spPr>
-      </p:pic>
-      <p:pic>
-        <p:nvPicPr>
-          <p:cNvPr id="6" name="Image 1" descr="preencoded.png">    </p:cNvPr>
-          <p:cNvPicPr>
-            <a:picLocks noChangeAspect="1"/>
-          </p:cNvPicPr>
-          <p:nvPr/>
-        </p:nvPicPr>
-        <p:blipFill>
-          <a:blip r:embed="rId2">
-            <a:alphaModFix amt="40000"/>
-          </a:blip>
-          <a:stretch>
-            <a:fillRect/>
-          </a:stretch>
-        </p:blipFill>
-        <p:spPr>
-          <a:xfrm>
-            <a:off x="7955280" y="1097280"/>
-            <a:ext cx="502920" cy="502920"/>
-          </a:xfrm>
-          <a:prstGeom prst="rect">
-            <a:avLst/>
-          </a:prstGeom>
-        </p:spPr>
-      </p:pic>
-      <p:pic>
-        <p:nvPicPr>
-          <p:cNvPr id="7" name="Image 2" descr="preencoded.png">    </p:cNvPr>
+          <p:cNvPr id="5" name="Image 0" descr="preencoded.png"/>
           <p:cNvPicPr>
             <a:picLocks noChangeAspect="1"/>
           </p:cNvPicPr>
@@ -1545,6 +1273,58 @@
         </p:blipFill>
         <p:spPr>
           <a:xfrm>
+            <a:off x="6949440" y="640080"/>
+            <a:ext cx="640080" cy="640080"/>
+          </a:xfrm>
+          <a:prstGeom prst="rect">
+            <a:avLst/>
+          </a:prstGeom>
+        </p:spPr>
+      </p:pic>
+      <p:pic>
+        <p:nvPicPr>
+          <p:cNvPr id="6" name="Image 1" descr="preencoded.png"/>
+          <p:cNvPicPr>
+            <a:picLocks noChangeAspect="1"/>
+          </p:cNvPicPr>
+          <p:nvPr/>
+        </p:nvPicPr>
+        <p:blipFill>
+          <a:blip r:embed="rId4">
+            <a:alphaModFix amt="40000"/>
+          </a:blip>
+          <a:stretch>
+            <a:fillRect/>
+          </a:stretch>
+        </p:blipFill>
+        <p:spPr>
+          <a:xfrm>
+            <a:off x="7955280" y="1097280"/>
+            <a:ext cx="502920" cy="502920"/>
+          </a:xfrm>
+          <a:prstGeom prst="rect">
+            <a:avLst/>
+          </a:prstGeom>
+        </p:spPr>
+      </p:pic>
+      <p:pic>
+        <p:nvPicPr>
+          <p:cNvPr id="7" name="Image 2" descr="preencoded.png"/>
+          <p:cNvPicPr>
+            <a:picLocks noChangeAspect="1"/>
+          </p:cNvPicPr>
+          <p:nvPr/>
+        </p:nvPicPr>
+        <p:blipFill>
+          <a:blip r:embed="rId5">
+            <a:alphaModFix amt="40000"/>
+          </a:blip>
+          <a:stretch>
+            <a:fillRect/>
+          </a:stretch>
+        </p:blipFill>
+        <p:spPr>
+          <a:xfrm>
             <a:off x="7406640" y="2011680"/>
             <a:ext cx="548640" cy="548640"/>
           </a:xfrm>
@@ -1572,6 +1352,13 @@
           </a:solidFill>
           <a:ln/>
         </p:spPr>
+        <p:txBody>
+          <a:bodyPr/>
+          <a:lstStyle/>
+          <a:p>
+            <a:endParaRPr lang="en-US"/>
+          </a:p>
+        </p:txBody>
       </p:sp>
       <p:sp>
         <p:nvSpPr>
@@ -1594,7 +1381,7 @@
           <a:bodyPr wrap="square" rtlCol="0" anchor="ctr"/>
           <a:lstStyle/>
           <a:p>
-            <a:pPr algn="l" indent="0" marL="0">
+            <a:pPr marL="0" indent="0" algn="l">
               <a:lnSpc>
                 <a:spcPct val="110000"/>
               </a:lnSpc>
@@ -1614,7 +1401,7 @@
             <a:endParaRPr lang="en-US" sz="4000" dirty="0"/>
           </a:p>
           <a:p>
-            <a:pPr algn="l" indent="0" marL="0">
+            <a:pPr marL="0" indent="0" algn="l">
               <a:lnSpc>
                 <a:spcPct val="110000"/>
               </a:lnSpc>
@@ -1656,7 +1443,7 @@
           <a:bodyPr wrap="square" rtlCol="0" anchor="ctr"/>
           <a:lstStyle/>
           <a:p>
-            <a:pPr algn="l" indent="0" marL="0">
+            <a:pPr marL="0" indent="0" algn="l">
               <a:buNone/>
             </a:pPr>
             <a:r>
@@ -1695,7 +1482,7 @@
           <a:bodyPr wrap="square" rtlCol="0" anchor="ctr"/>
           <a:lstStyle/>
           <a:p>
-            <a:pPr algn="l" indent="0" marL="0">
+            <a:pPr marL="0" indent="0" algn="l">
               <a:buNone/>
             </a:pPr>
             <a:r>
@@ -1729,6 +1516,7 @@
         <a:solidFill>
           <a:srgbClr val="0A2342"/>
         </a:solidFill>
+        <a:effectLst/>
       </p:bgPr>
     </p:bg>
     <p:spTree>
@@ -1764,6 +1552,13 @@
           </a:solidFill>
           <a:ln/>
         </p:spPr>
+        <p:txBody>
+          <a:bodyPr/>
+          <a:lstStyle/>
+          <a:p>
+            <a:endParaRPr lang="en-US"/>
+          </a:p>
+        </p:txBody>
       </p:sp>
       <p:sp>
         <p:nvSpPr>
@@ -1786,6 +1581,13 @@
           </a:solidFill>
           <a:ln/>
         </p:spPr>
+        <p:txBody>
+          <a:bodyPr/>
+          <a:lstStyle/>
+          <a:p>
+            <a:endParaRPr lang="en-US"/>
+          </a:p>
+        </p:txBody>
       </p:sp>
       <p:sp>
         <p:nvSpPr>
@@ -1808,7 +1610,7 @@
           <a:bodyPr wrap="square" lIns="0" tIns="0" rIns="0" bIns="0" rtlCol="0" anchor="ctr"/>
           <a:lstStyle/>
           <a:p>
-            <a:pPr algn="l" indent="0" marL="0">
+            <a:pPr marL="0" indent="0" algn="l">
               <a:buNone/>
             </a:pPr>
             <a:r>
@@ -1847,7 +1649,7 @@
           <a:bodyPr wrap="square" lIns="0" tIns="0" rIns="0" bIns="0" rtlCol="0" anchor="ctr"/>
           <a:lstStyle/>
           <a:p>
-            <a:pPr algn="l" indent="0" marL="0">
+            <a:pPr marL="0" indent="0" algn="l">
               <a:buNone/>
             </a:pPr>
             <a:r>
@@ -1889,13 +1691,20 @@
             <a:prstDash val="solid"/>
           </a:ln>
           <a:effectLst>
-            <a:outerShdw sx="100000" sy="100000" kx="0" ky="0" algn="bl" rotWithShape="0" blurRad="101600" dist="25400" dir="8100000">
+            <a:outerShdw blurRad="101600" dist="25400" dir="8100000" algn="bl" rotWithShape="0">
               <a:srgbClr val="000000">
                 <a:alpha val="10000"/>
               </a:srgbClr>
             </a:outerShdw>
           </a:effectLst>
         </p:spPr>
+        <p:txBody>
+          <a:bodyPr/>
+          <a:lstStyle/>
+          <a:p>
+            <a:endParaRPr lang="en-US"/>
+          </a:p>
+        </p:txBody>
       </p:sp>
       <p:sp>
         <p:nvSpPr>
@@ -1916,6 +1725,13 @@
           </a:solidFill>
           <a:ln/>
         </p:spPr>
+        <p:txBody>
+          <a:bodyPr/>
+          <a:lstStyle/>
+          <a:p>
+            <a:endParaRPr lang="en-US"/>
+          </a:p>
+        </p:txBody>
       </p:sp>
       <p:sp>
         <p:nvSpPr>
@@ -1936,17 +1752,24 @@
           </a:solidFill>
           <a:ln/>
         </p:spPr>
+        <p:txBody>
+          <a:bodyPr/>
+          <a:lstStyle/>
+          <a:p>
+            <a:endParaRPr lang="en-US"/>
+          </a:p>
+        </p:txBody>
       </p:sp>
       <p:pic>
         <p:nvPicPr>
-          <p:cNvPr id="9" name="Image 0" descr="preencoded.png">    </p:cNvPr>
+          <p:cNvPr id="9" name="Image 0" descr="preencoded.png"/>
           <p:cNvPicPr>
             <a:picLocks noChangeAspect="1"/>
           </p:cNvPicPr>
           <p:nvPr/>
         </p:nvPicPr>
         <p:blipFill>
-          <a:blip r:embed="rId1"/>
+          <a:blip r:embed="rId3"/>
           <a:stretch>
             <a:fillRect/>
           </a:stretch>
@@ -1982,7 +1805,7 @@
           <a:bodyPr wrap="square" lIns="0" tIns="0" rIns="0" bIns="0" rtlCol="0" anchor="ctr"/>
           <a:lstStyle/>
           <a:p>
-            <a:pPr algn="l" indent="0" marL="0">
+            <a:pPr marL="0" indent="0" algn="l">
               <a:buNone/>
             </a:pPr>
             <a:r>
@@ -2021,7 +1844,7 @@
           <a:bodyPr wrap="square" rtlCol="0" anchor="t"/>
           <a:lstStyle/>
           <a:p>
-            <a:pPr algn="l" indent="0" marL="0">
+            <a:pPr marL="0" indent="0" algn="l">
               <a:buNone/>
             </a:pPr>
             <a:r>
@@ -2063,13 +1886,20 @@
             <a:prstDash val="solid"/>
           </a:ln>
           <a:effectLst>
-            <a:outerShdw sx="100000" sy="100000" kx="0" ky="0" algn="bl" rotWithShape="0" blurRad="101600" dist="25400" dir="8100000">
+            <a:outerShdw blurRad="101600" dist="25400" dir="8100000" algn="bl" rotWithShape="0">
               <a:srgbClr val="000000">
                 <a:alpha val="10000"/>
               </a:srgbClr>
             </a:outerShdw>
           </a:effectLst>
         </p:spPr>
+        <p:txBody>
+          <a:bodyPr/>
+          <a:lstStyle/>
+          <a:p>
+            <a:endParaRPr lang="en-US"/>
+          </a:p>
+        </p:txBody>
       </p:sp>
       <p:sp>
         <p:nvSpPr>
@@ -2090,6 +1920,13 @@
           </a:solidFill>
           <a:ln/>
         </p:spPr>
+        <p:txBody>
+          <a:bodyPr/>
+          <a:lstStyle/>
+          <a:p>
+            <a:endParaRPr lang="en-US"/>
+          </a:p>
+        </p:txBody>
       </p:sp>
       <p:sp>
         <p:nvSpPr>
@@ -2110,17 +1947,24 @@
           </a:solidFill>
           <a:ln/>
         </p:spPr>
+        <p:txBody>
+          <a:bodyPr/>
+          <a:lstStyle/>
+          <a:p>
+            <a:endParaRPr lang="en-US"/>
+          </a:p>
+        </p:txBody>
       </p:sp>
       <p:pic>
         <p:nvPicPr>
-          <p:cNvPr id="15" name="Image 1" descr="preencoded.png">    </p:cNvPr>
+          <p:cNvPr id="15" name="Image 1" descr="preencoded.png"/>
           <p:cNvPicPr>
             <a:picLocks noChangeAspect="1"/>
           </p:cNvPicPr>
           <p:nvPr/>
         </p:nvPicPr>
         <p:blipFill>
-          <a:blip r:embed="rId2"/>
+          <a:blip r:embed="rId4"/>
           <a:stretch>
             <a:fillRect/>
           </a:stretch>
@@ -2156,7 +2000,7 @@
           <a:bodyPr wrap="square" lIns="0" tIns="0" rIns="0" bIns="0" rtlCol="0" anchor="ctr"/>
           <a:lstStyle/>
           <a:p>
-            <a:pPr algn="l" indent="0" marL="0">
+            <a:pPr marL="0" indent="0" algn="l">
               <a:buNone/>
             </a:pPr>
             <a:r>
@@ -2195,7 +2039,7 @@
           <a:bodyPr wrap="square" rtlCol="0" anchor="t"/>
           <a:lstStyle/>
           <a:p>
-            <a:pPr algn="l" indent="0" marL="0">
+            <a:pPr marL="0" indent="0" algn="l">
               <a:buNone/>
             </a:pPr>
             <a:r>
@@ -2237,13 +2081,20 @@
             <a:prstDash val="solid"/>
           </a:ln>
           <a:effectLst>
-            <a:outerShdw sx="100000" sy="100000" kx="0" ky="0" algn="bl" rotWithShape="0" blurRad="101600" dist="25400" dir="8100000">
+            <a:outerShdw blurRad="101600" dist="25400" dir="8100000" algn="bl" rotWithShape="0">
               <a:srgbClr val="000000">
                 <a:alpha val="10000"/>
               </a:srgbClr>
             </a:outerShdw>
           </a:effectLst>
         </p:spPr>
+        <p:txBody>
+          <a:bodyPr/>
+          <a:lstStyle/>
+          <a:p>
+            <a:endParaRPr lang="en-US"/>
+          </a:p>
+        </p:txBody>
       </p:sp>
       <p:sp>
         <p:nvSpPr>
@@ -2264,6 +2115,13 @@
           </a:solidFill>
           <a:ln/>
         </p:spPr>
+        <p:txBody>
+          <a:bodyPr/>
+          <a:lstStyle/>
+          <a:p>
+            <a:endParaRPr lang="en-US"/>
+          </a:p>
+        </p:txBody>
       </p:sp>
       <p:sp>
         <p:nvSpPr>
@@ -2284,17 +2142,24 @@
           </a:solidFill>
           <a:ln/>
         </p:spPr>
+        <p:txBody>
+          <a:bodyPr/>
+          <a:lstStyle/>
+          <a:p>
+            <a:endParaRPr lang="en-US"/>
+          </a:p>
+        </p:txBody>
       </p:sp>
       <p:pic>
         <p:nvPicPr>
-          <p:cNvPr id="21" name="Image 2" descr="preencoded.png">    </p:cNvPr>
+          <p:cNvPr id="21" name="Image 2" descr="preencoded.png"/>
           <p:cNvPicPr>
             <a:picLocks noChangeAspect="1"/>
           </p:cNvPicPr>
           <p:nvPr/>
         </p:nvPicPr>
         <p:blipFill>
-          <a:blip r:embed="rId3"/>
+          <a:blip r:embed="rId5"/>
           <a:stretch>
             <a:fillRect/>
           </a:stretch>
@@ -2330,7 +2195,7 @@
           <a:bodyPr wrap="square" lIns="0" tIns="0" rIns="0" bIns="0" rtlCol="0" anchor="ctr"/>
           <a:lstStyle/>
           <a:p>
-            <a:pPr algn="l" indent="0" marL="0">
+            <a:pPr marL="0" indent="0" algn="l">
               <a:buNone/>
             </a:pPr>
             <a:r>
@@ -2369,7 +2234,7 @@
           <a:bodyPr wrap="square" rtlCol="0" anchor="t"/>
           <a:lstStyle/>
           <a:p>
-            <a:pPr algn="l" indent="0" marL="0">
+            <a:pPr marL="0" indent="0" algn="l">
               <a:buNone/>
             </a:pPr>
             <a:r>
@@ -2411,13 +2276,20 @@
             <a:prstDash val="solid"/>
           </a:ln>
           <a:effectLst>
-            <a:outerShdw sx="100000" sy="100000" kx="0" ky="0" algn="bl" rotWithShape="0" blurRad="101600" dist="25400" dir="8100000">
+            <a:outerShdw blurRad="101600" dist="25400" dir="8100000" algn="bl" rotWithShape="0">
               <a:srgbClr val="000000">
                 <a:alpha val="10000"/>
               </a:srgbClr>
             </a:outerShdw>
           </a:effectLst>
         </p:spPr>
+        <p:txBody>
+          <a:bodyPr/>
+          <a:lstStyle/>
+          <a:p>
+            <a:endParaRPr lang="en-US"/>
+          </a:p>
+        </p:txBody>
       </p:sp>
       <p:sp>
         <p:nvSpPr>
@@ -2438,6 +2310,13 @@
           </a:solidFill>
           <a:ln/>
         </p:spPr>
+        <p:txBody>
+          <a:bodyPr/>
+          <a:lstStyle/>
+          <a:p>
+            <a:endParaRPr lang="en-US"/>
+          </a:p>
+        </p:txBody>
       </p:sp>
       <p:sp>
         <p:nvSpPr>
@@ -2458,17 +2337,24 @@
           </a:solidFill>
           <a:ln/>
         </p:spPr>
+        <p:txBody>
+          <a:bodyPr/>
+          <a:lstStyle/>
+          <a:p>
+            <a:endParaRPr lang="en-US"/>
+          </a:p>
+        </p:txBody>
       </p:sp>
       <p:pic>
         <p:nvPicPr>
-          <p:cNvPr id="27" name="Image 3" descr="preencoded.png">    </p:cNvPr>
+          <p:cNvPr id="27" name="Image 3" descr="preencoded.png"/>
           <p:cNvPicPr>
             <a:picLocks noChangeAspect="1"/>
           </p:cNvPicPr>
           <p:nvPr/>
         </p:nvPicPr>
         <p:blipFill>
-          <a:blip r:embed="rId4"/>
+          <a:blip r:embed="rId6"/>
           <a:stretch>
             <a:fillRect/>
           </a:stretch>
@@ -2504,7 +2390,7 @@
           <a:bodyPr wrap="square" lIns="0" tIns="0" rIns="0" bIns="0" rtlCol="0" anchor="ctr"/>
           <a:lstStyle/>
           <a:p>
-            <a:pPr algn="l" indent="0" marL="0">
+            <a:pPr marL="0" indent="0" algn="l">
               <a:buNone/>
             </a:pPr>
             <a:r>
@@ -2543,7 +2429,7 @@
           <a:bodyPr wrap="square" rtlCol="0" anchor="t"/>
           <a:lstStyle/>
           <a:p>
-            <a:pPr algn="l" indent="0" marL="0">
+            <a:pPr marL="0" indent="0" algn="l">
               <a:buNone/>
             </a:pPr>
             <a:r>
@@ -2585,13 +2471,20 @@
             <a:prstDash val="solid"/>
           </a:ln>
           <a:effectLst>
-            <a:outerShdw sx="100000" sy="100000" kx="0" ky="0" algn="bl" rotWithShape="0" blurRad="101600" dist="25400" dir="8100000">
+            <a:outerShdw blurRad="101600" dist="25400" dir="8100000" algn="bl" rotWithShape="0">
               <a:srgbClr val="000000">
                 <a:alpha val="10000"/>
               </a:srgbClr>
             </a:outerShdw>
           </a:effectLst>
         </p:spPr>
+        <p:txBody>
+          <a:bodyPr/>
+          <a:lstStyle/>
+          <a:p>
+            <a:endParaRPr lang="en-US"/>
+          </a:p>
+        </p:txBody>
       </p:sp>
       <p:sp>
         <p:nvSpPr>
@@ -2612,6 +2505,13 @@
           </a:solidFill>
           <a:ln/>
         </p:spPr>
+        <p:txBody>
+          <a:bodyPr/>
+          <a:lstStyle/>
+          <a:p>
+            <a:endParaRPr lang="en-US"/>
+          </a:p>
+        </p:txBody>
       </p:sp>
       <p:sp>
         <p:nvSpPr>
@@ -2632,17 +2532,24 @@
           </a:solidFill>
           <a:ln/>
         </p:spPr>
+        <p:txBody>
+          <a:bodyPr/>
+          <a:lstStyle/>
+          <a:p>
+            <a:endParaRPr lang="en-US"/>
+          </a:p>
+        </p:txBody>
       </p:sp>
       <p:pic>
         <p:nvPicPr>
-          <p:cNvPr id="33" name="Image 4" descr="preencoded.png">    </p:cNvPr>
+          <p:cNvPr id="33" name="Image 4" descr="preencoded.png"/>
           <p:cNvPicPr>
             <a:picLocks noChangeAspect="1"/>
           </p:cNvPicPr>
           <p:nvPr/>
         </p:nvPicPr>
         <p:blipFill>
-          <a:blip r:embed="rId5"/>
+          <a:blip r:embed="rId7"/>
           <a:stretch>
             <a:fillRect/>
           </a:stretch>
@@ -2678,7 +2585,7 @@
           <a:bodyPr wrap="square" lIns="0" tIns="0" rIns="0" bIns="0" rtlCol="0" anchor="ctr"/>
           <a:lstStyle/>
           <a:p>
-            <a:pPr algn="l" indent="0" marL="0">
+            <a:pPr marL="0" indent="0" algn="l">
               <a:buNone/>
             </a:pPr>
             <a:r>
@@ -2717,7 +2624,7 @@
           <a:bodyPr wrap="square" rtlCol="0" anchor="t"/>
           <a:lstStyle/>
           <a:p>
-            <a:pPr algn="l" indent="0" marL="0">
+            <a:pPr marL="0" indent="0" algn="l">
               <a:buNone/>
             </a:pPr>
             <a:r>
@@ -2759,13 +2666,20 @@
             <a:prstDash val="solid"/>
           </a:ln>
           <a:effectLst>
-            <a:outerShdw sx="100000" sy="100000" kx="0" ky="0" algn="bl" rotWithShape="0" blurRad="101600" dist="25400" dir="8100000">
+            <a:outerShdw blurRad="101600" dist="25400" dir="8100000" algn="bl" rotWithShape="0">
               <a:srgbClr val="000000">
                 <a:alpha val="10000"/>
               </a:srgbClr>
             </a:outerShdw>
           </a:effectLst>
         </p:spPr>
+        <p:txBody>
+          <a:bodyPr/>
+          <a:lstStyle/>
+          <a:p>
+            <a:endParaRPr lang="en-US"/>
+          </a:p>
+        </p:txBody>
       </p:sp>
       <p:sp>
         <p:nvSpPr>
@@ -2786,6 +2700,13 @@
           </a:solidFill>
           <a:ln/>
         </p:spPr>
+        <p:txBody>
+          <a:bodyPr/>
+          <a:lstStyle/>
+          <a:p>
+            <a:endParaRPr lang="en-US"/>
+          </a:p>
+        </p:txBody>
       </p:sp>
       <p:sp>
         <p:nvSpPr>
@@ -2806,17 +2727,24 @@
           </a:solidFill>
           <a:ln/>
         </p:spPr>
+        <p:txBody>
+          <a:bodyPr/>
+          <a:lstStyle/>
+          <a:p>
+            <a:endParaRPr lang="en-US"/>
+          </a:p>
+        </p:txBody>
       </p:sp>
       <p:pic>
         <p:nvPicPr>
-          <p:cNvPr id="39" name="Image 5" descr="preencoded.png">    </p:cNvPr>
+          <p:cNvPr id="39" name="Image 5" descr="preencoded.png"/>
           <p:cNvPicPr>
             <a:picLocks noChangeAspect="1"/>
           </p:cNvPicPr>
           <p:nvPr/>
         </p:nvPicPr>
         <p:blipFill>
-          <a:blip r:embed="rId6"/>
+          <a:blip r:embed="rId8"/>
           <a:stretch>
             <a:fillRect/>
           </a:stretch>
@@ -2852,7 +2780,7 @@
           <a:bodyPr wrap="square" lIns="0" tIns="0" rIns="0" bIns="0" rtlCol="0" anchor="ctr"/>
           <a:lstStyle/>
           <a:p>
-            <a:pPr algn="l" indent="0" marL="0">
+            <a:pPr marL="0" indent="0" algn="l">
               <a:buNone/>
             </a:pPr>
             <a:r>
@@ -2891,7 +2819,7 @@
           <a:bodyPr wrap="square" rtlCol="0" anchor="t"/>
           <a:lstStyle/>
           <a:p>
-            <a:pPr algn="l" indent="0" marL="0">
+            <a:pPr marL="0" indent="0" algn="l">
               <a:buNone/>
             </a:pPr>
             <a:r>
@@ -2925,6 +2853,7 @@
         <a:solidFill>
           <a:srgbClr val="F0F4F8"/>
         </a:solidFill>
+        <a:effectLst/>
       </p:bgPr>
     </p:bg>
     <p:spTree>
@@ -2962,7 +2891,7 @@
           <a:bodyPr wrap="square" lIns="0" tIns="0" rIns="0" bIns="0" rtlCol="0" anchor="ctr"/>
           <a:lstStyle/>
           <a:p>
-            <a:pPr algn="l" indent="0" marL="0">
+            <a:pPr marL="0" indent="0" algn="l">
               <a:buNone/>
             </a:pPr>
             <a:r>
@@ -3004,13 +2933,20 @@
             <a:prstDash val="solid"/>
           </a:ln>
           <a:effectLst>
-            <a:outerShdw sx="100000" sy="100000" kx="0" ky="0" algn="bl" rotWithShape="0" blurRad="101600" dist="25400" dir="8100000">
+            <a:outerShdw blurRad="101600" dist="25400" dir="8100000" algn="bl" rotWithShape="0">
               <a:srgbClr val="000000">
                 <a:alpha val="10000"/>
               </a:srgbClr>
             </a:outerShdw>
           </a:effectLst>
         </p:spPr>
+        <p:txBody>
+          <a:bodyPr/>
+          <a:lstStyle/>
+          <a:p>
+            <a:endParaRPr lang="en-US"/>
+          </a:p>
+        </p:txBody>
       </p:sp>
       <p:sp>
         <p:nvSpPr>
@@ -3033,7 +2969,7 @@
           <a:bodyPr wrap="square" lIns="0" tIns="0" rIns="0" bIns="0" rtlCol="0" anchor="ctr"/>
           <a:lstStyle/>
           <a:p>
-            <a:pPr algn="ctr" indent="0" marL="0">
+            <a:pPr marL="0" indent="0" algn="ctr">
               <a:buNone/>
             </a:pPr>
             <a:r>
@@ -3072,7 +3008,7 @@
           <a:bodyPr wrap="square" lIns="0" tIns="0" rIns="0" bIns="0" rtlCol="0" anchor="ctr"/>
           <a:lstStyle/>
           <a:p>
-            <a:pPr algn="l" indent="0" marL="0">
+            <a:pPr marL="0" indent="0" algn="l">
               <a:buNone/>
             </a:pPr>
             <a:r>
@@ -3089,7 +3025,7 @@
             <a:endParaRPr lang="en-US" sz="900" dirty="0"/>
           </a:p>
           <a:p>
-            <a:pPr algn="l" indent="0" marL="0">
+            <a:pPr marL="0" indent="0" algn="l">
               <a:buNone/>
             </a:pPr>
             <a:r>
@@ -3131,13 +3067,20 @@
             <a:prstDash val="solid"/>
           </a:ln>
           <a:effectLst>
-            <a:outerShdw sx="100000" sy="100000" kx="0" ky="0" algn="bl" rotWithShape="0" blurRad="101600" dist="25400" dir="8100000">
+            <a:outerShdw blurRad="101600" dist="25400" dir="8100000" algn="bl" rotWithShape="0">
               <a:srgbClr val="000000">
                 <a:alpha val="10000"/>
               </a:srgbClr>
             </a:outerShdw>
           </a:effectLst>
         </p:spPr>
+        <p:txBody>
+          <a:bodyPr/>
+          <a:lstStyle/>
+          <a:p>
+            <a:endParaRPr lang="en-US"/>
+          </a:p>
+        </p:txBody>
       </p:sp>
       <p:sp>
         <p:nvSpPr>
@@ -3160,7 +3103,7 @@
           <a:bodyPr wrap="square" lIns="0" tIns="0" rIns="0" bIns="0" rtlCol="0" anchor="ctr"/>
           <a:lstStyle/>
           <a:p>
-            <a:pPr algn="ctr" indent="0" marL="0">
+            <a:pPr marL="0" indent="0" algn="ctr">
               <a:buNone/>
             </a:pPr>
             <a:r>
@@ -3199,7 +3142,7 @@
           <a:bodyPr wrap="square" lIns="0" tIns="0" rIns="0" bIns="0" rtlCol="0" anchor="ctr"/>
           <a:lstStyle/>
           <a:p>
-            <a:pPr algn="l" indent="0" marL="0">
+            <a:pPr marL="0" indent="0" algn="l">
               <a:buNone/>
             </a:pPr>
             <a:r>
@@ -3216,7 +3159,7 @@
             <a:endParaRPr lang="en-US" sz="900" dirty="0"/>
           </a:p>
           <a:p>
-            <a:pPr algn="l" indent="0" marL="0">
+            <a:pPr marL="0" indent="0" algn="l">
               <a:buNone/>
             </a:pPr>
             <a:r>
@@ -3258,13 +3201,20 @@
             <a:prstDash val="solid"/>
           </a:ln>
           <a:effectLst>
-            <a:outerShdw sx="100000" sy="100000" kx="0" ky="0" algn="bl" rotWithShape="0" blurRad="101600" dist="25400" dir="8100000">
+            <a:outerShdw blurRad="101600" dist="25400" dir="8100000" algn="bl" rotWithShape="0">
               <a:srgbClr val="000000">
                 <a:alpha val="10000"/>
               </a:srgbClr>
             </a:outerShdw>
           </a:effectLst>
         </p:spPr>
+        <p:txBody>
+          <a:bodyPr/>
+          <a:lstStyle/>
+          <a:p>
+            <a:endParaRPr lang="en-US"/>
+          </a:p>
+        </p:txBody>
       </p:sp>
       <p:sp>
         <p:nvSpPr>
@@ -3287,7 +3237,7 @@
           <a:bodyPr wrap="square" lIns="0" tIns="0" rIns="0" bIns="0" rtlCol="0" anchor="ctr"/>
           <a:lstStyle/>
           <a:p>
-            <a:pPr algn="ctr" indent="0" marL="0">
+            <a:pPr marL="0" indent="0" algn="ctr">
               <a:buNone/>
             </a:pPr>
             <a:r>
@@ -3326,7 +3276,7 @@
           <a:bodyPr wrap="square" lIns="0" tIns="0" rIns="0" bIns="0" rtlCol="0" anchor="ctr"/>
           <a:lstStyle/>
           <a:p>
-            <a:pPr algn="l" indent="0" marL="0">
+            <a:pPr marL="0" indent="0" algn="l">
               <a:buNone/>
             </a:pPr>
             <a:r>
@@ -3343,7 +3293,7 @@
             <a:endParaRPr lang="en-US" sz="900" dirty="0"/>
           </a:p>
           <a:p>
-            <a:pPr algn="l" indent="0" marL="0">
+            <a:pPr marL="0" indent="0" algn="l">
               <a:buNone/>
             </a:pPr>
             <a:r>
@@ -3382,7 +3332,7 @@
           <a:bodyPr wrap="square" lIns="0" tIns="0" rIns="0" bIns="0" rtlCol="0" anchor="ctr"/>
           <a:lstStyle/>
           <a:p>
-            <a:pPr algn="l" indent="0" marL="0">
+            <a:pPr marL="0" indent="0" algn="l">
               <a:buNone/>
             </a:pPr>
             <a:r>
@@ -3419,6 +3369,13 @@
           </a:solidFill>
           <a:ln/>
         </p:spPr>
+        <p:txBody>
+          <a:bodyPr/>
+          <a:lstStyle/>
+          <a:p>
+            <a:endParaRPr lang="en-US"/>
+          </a:p>
+        </p:txBody>
       </p:sp>
       <p:sp>
         <p:nvSpPr>
@@ -3444,13 +3401,20 @@
             <a:prstDash val="solid"/>
           </a:ln>
           <a:effectLst>
-            <a:outerShdw sx="100000" sy="100000" kx="0" ky="0" algn="bl" rotWithShape="0" blurRad="101600" dist="25400" dir="8100000">
+            <a:outerShdw blurRad="101600" dist="25400" dir="8100000" algn="bl" rotWithShape="0">
               <a:srgbClr val="000000">
                 <a:alpha val="10000"/>
               </a:srgbClr>
             </a:outerShdw>
           </a:effectLst>
         </p:spPr>
+        <p:txBody>
+          <a:bodyPr/>
+          <a:lstStyle/>
+          <a:p>
+            <a:endParaRPr lang="en-US"/>
+          </a:p>
+        </p:txBody>
       </p:sp>
       <p:sp>
         <p:nvSpPr>
@@ -3471,17 +3435,24 @@
           </a:solidFill>
           <a:ln/>
         </p:spPr>
+        <p:txBody>
+          <a:bodyPr/>
+          <a:lstStyle/>
+          <a:p>
+            <a:endParaRPr lang="en-US"/>
+          </a:p>
+        </p:txBody>
       </p:sp>
       <p:pic>
         <p:nvPicPr>
-          <p:cNvPr id="16" name="Image 0" descr="preencoded.png">    </p:cNvPr>
+          <p:cNvPr id="16" name="Image 0" descr="preencoded.png"/>
           <p:cNvPicPr>
             <a:picLocks noChangeAspect="1"/>
           </p:cNvPicPr>
           <p:nvPr/>
         </p:nvPicPr>
         <p:blipFill>
-          <a:blip r:embed="rId1"/>
+          <a:blip r:embed="rId3"/>
           <a:stretch>
             <a:fillRect/>
           </a:stretch>
@@ -3517,11 +3488,11 @@
           <a:bodyPr wrap="square" lIns="0" tIns="0" rIns="0" bIns="0" rtlCol="0" anchor="ctr"/>
           <a:lstStyle/>
           <a:p>
-            <a:pPr algn="l" indent="0" marL="0">
-              <a:buNone/>
-            </a:pPr>
-            <a:r>
-              <a:rPr lang="en-US" sz="900" b="1" spc="200" kern="0" dirty="0">
+            <a:pPr marL="0" indent="0" algn="l">
+              <a:buNone/>
+            </a:pPr>
+            <a:r>
+              <a:rPr lang="en-US" sz="900" b="1" kern="0" spc="200" dirty="0">
                 <a:solidFill>
                   <a:srgbClr val="FFFFFF"/>
                 </a:solidFill>
@@ -3722,7 +3693,7 @@
           <a:bodyPr wrap="square" lIns="0" tIns="0" rIns="0" bIns="0" rtlCol="0" anchor="ctr"/>
           <a:lstStyle/>
           <a:p>
-            <a:pPr algn="ctr" indent="0" marL="0">
+            <a:pPr marL="0" indent="0" algn="ctr">
               <a:buNone/>
             </a:pPr>
             <a:r>
@@ -3761,13 +3732,20 @@
             <a:prstDash val="solid"/>
           </a:ln>
           <a:effectLst>
-            <a:outerShdw sx="100000" sy="100000" kx="0" ky="0" algn="bl" rotWithShape="0" blurRad="177800" dist="50800" dir="8100000">
+            <a:outerShdw blurRad="177800" dist="50800" dir="8100000" algn="bl" rotWithShape="0">
               <a:srgbClr val="000000">
                 <a:alpha val="15000"/>
               </a:srgbClr>
             </a:outerShdw>
           </a:effectLst>
         </p:spPr>
+        <p:txBody>
+          <a:bodyPr/>
+          <a:lstStyle/>
+          <a:p>
+            <a:endParaRPr lang="en-US"/>
+          </a:p>
+        </p:txBody>
       </p:sp>
       <p:sp>
         <p:nvSpPr>
@@ -3788,17 +3766,24 @@
           </a:solidFill>
           <a:ln/>
         </p:spPr>
+        <p:txBody>
+          <a:bodyPr/>
+          <a:lstStyle/>
+          <a:p>
+            <a:endParaRPr lang="en-US"/>
+          </a:p>
+        </p:txBody>
       </p:sp>
       <p:pic>
         <p:nvPicPr>
-          <p:cNvPr id="22" name="Image 1" descr="preencoded.png">    </p:cNvPr>
+          <p:cNvPr id="22" name="Image 1" descr="preencoded.png"/>
           <p:cNvPicPr>
             <a:picLocks noChangeAspect="1"/>
           </p:cNvPicPr>
           <p:nvPr/>
         </p:nvPicPr>
         <p:blipFill>
-          <a:blip r:embed="rId2"/>
+          <a:blip r:embed="rId4"/>
           <a:stretch>
             <a:fillRect/>
           </a:stretch>
@@ -3834,11 +3819,11 @@
           <a:bodyPr wrap="square" lIns="0" tIns="0" rIns="0" bIns="0" rtlCol="0" anchor="ctr"/>
           <a:lstStyle/>
           <a:p>
-            <a:pPr algn="l" indent="0" marL="0">
-              <a:buNone/>
-            </a:pPr>
-            <a:r>
-              <a:rPr lang="en-US" sz="900" b="1" spc="200" kern="0" dirty="0">
+            <a:pPr marL="0" indent="0" algn="l">
+              <a:buNone/>
+            </a:pPr>
+            <a:r>
+              <a:rPr lang="en-US" sz="900" b="1" kern="0" spc="200" dirty="0">
                 <a:solidFill>
                   <a:srgbClr val="0A2342"/>
                 </a:solidFill>
@@ -3873,7 +3858,7 @@
           <a:bodyPr wrap="square" lIns="0" tIns="0" rIns="0" bIns="0" rtlCol="0" anchor="ctr"/>
           <a:lstStyle/>
           <a:p>
-            <a:pPr algn="l" indent="0" marL="0">
+            <a:pPr marL="0" indent="0" algn="l">
               <a:buNone/>
             </a:pPr>
             <a:r>
@@ -4078,7 +4063,7 @@
           <a:bodyPr wrap="square" lIns="0" tIns="0" rIns="0" bIns="0" rtlCol="0" anchor="ctr"/>
           <a:lstStyle/>
           <a:p>
-            <a:pPr algn="ctr" indent="0" marL="0">
+            <a:pPr marL="0" indent="0" algn="ctr">
               <a:buNone/>
             </a:pPr>
             <a:r>
@@ -4117,13 +4102,20 @@
             <a:prstDash val="solid"/>
           </a:ln>
           <a:effectLst>
-            <a:outerShdw sx="100000" sy="100000" kx="0" ky="0" algn="bl" rotWithShape="0" blurRad="101600" dist="25400" dir="8100000">
+            <a:outerShdw blurRad="101600" dist="25400" dir="8100000" algn="bl" rotWithShape="0">
               <a:srgbClr val="000000">
                 <a:alpha val="10000"/>
               </a:srgbClr>
             </a:outerShdw>
           </a:effectLst>
         </p:spPr>
+        <p:txBody>
+          <a:bodyPr/>
+          <a:lstStyle/>
+          <a:p>
+            <a:endParaRPr lang="en-US"/>
+          </a:p>
+        </p:txBody>
       </p:sp>
       <p:sp>
         <p:nvSpPr>
@@ -4144,17 +4136,24 @@
           </a:solidFill>
           <a:ln/>
         </p:spPr>
+        <p:txBody>
+          <a:bodyPr/>
+          <a:lstStyle/>
+          <a:p>
+            <a:endParaRPr lang="en-US"/>
+          </a:p>
+        </p:txBody>
       </p:sp>
       <p:pic>
         <p:nvPicPr>
-          <p:cNvPr id="29" name="Image 2" descr="preencoded.png">    </p:cNvPr>
+          <p:cNvPr id="29" name="Image 2" descr="preencoded.png"/>
           <p:cNvPicPr>
             <a:picLocks noChangeAspect="1"/>
           </p:cNvPicPr>
           <p:nvPr/>
         </p:nvPicPr>
         <p:blipFill>
-          <a:blip r:embed="rId3"/>
+          <a:blip r:embed="rId5"/>
           <a:stretch>
             <a:fillRect/>
           </a:stretch>
@@ -4190,11 +4189,11 @@
           <a:bodyPr wrap="square" lIns="0" tIns="0" rIns="0" bIns="0" rtlCol="0" anchor="ctr"/>
           <a:lstStyle/>
           <a:p>
-            <a:pPr algn="l" indent="0" marL="0">
-              <a:buNone/>
-            </a:pPr>
-            <a:r>
-              <a:rPr lang="en-US" sz="900" b="1" spc="200" kern="0" dirty="0">
+            <a:pPr marL="0" indent="0" algn="l">
+              <a:buNone/>
+            </a:pPr>
+            <a:r>
+              <a:rPr lang="en-US" sz="900" b="1" kern="0" spc="200" dirty="0">
                 <a:solidFill>
                   <a:srgbClr val="FFFFFF"/>
                 </a:solidFill>
@@ -4372,6 +4371,7 @@
         <a:solidFill>
           <a:srgbClr val="F0F4F8"/>
         </a:solidFill>
+        <a:effectLst/>
       </p:bgPr>
     </p:bg>
     <p:spTree>
@@ -4409,6 +4409,13 @@
           </a:solidFill>
           <a:ln/>
         </p:spPr>
+        <p:txBody>
+          <a:bodyPr/>
+          <a:lstStyle/>
+          <a:p>
+            <a:endParaRPr lang="en-US"/>
+          </a:p>
+        </p:txBody>
       </p:sp>
       <p:sp>
         <p:nvSpPr>
@@ -4431,7 +4438,7 @@
           <a:bodyPr wrap="square" lIns="0" tIns="0" rIns="0" bIns="0" rtlCol="0" anchor="ctr"/>
           <a:lstStyle/>
           <a:p>
-            <a:pPr algn="l" indent="0" marL="0">
+            <a:pPr marL="0" indent="0" algn="l">
               <a:buNone/>
             </a:pPr>
             <a:r>
@@ -4470,7 +4477,7 @@
           <a:bodyPr wrap="square" lIns="0" tIns="0" rIns="0" bIns="0" rtlCol="0" anchor="ctr"/>
           <a:lstStyle/>
           <a:p>
-            <a:pPr algn="l" indent="0" marL="0">
+            <a:pPr marL="0" indent="0" algn="l">
               <a:buNone/>
             </a:pPr>
             <a:r>
@@ -4509,7 +4516,7 @@
           <a:bodyPr wrap="square" lIns="0" tIns="0" rIns="0" bIns="0" rtlCol="0" anchor="ctr"/>
           <a:lstStyle/>
           <a:p>
-            <a:pPr algn="l" indent="0" marL="0">
+            <a:pPr marL="0" indent="0" algn="l">
               <a:buNone/>
             </a:pPr>
             <a:r>
@@ -4546,6 +4553,13 @@
           </a:solidFill>
           <a:ln/>
         </p:spPr>
+        <p:txBody>
+          <a:bodyPr/>
+          <a:lstStyle/>
+          <a:p>
+            <a:endParaRPr lang="en-US"/>
+          </a:p>
+        </p:txBody>
       </p:sp>
       <p:sp>
         <p:nvSpPr>
@@ -4571,13 +4585,20 @@
             <a:prstDash val="solid"/>
           </a:ln>
           <a:effectLst>
-            <a:outerShdw sx="100000" sy="100000" kx="0" ky="0" algn="bl" rotWithShape="0" blurRad="101600" dist="25400" dir="8100000">
+            <a:outerShdw blurRad="101600" dist="25400" dir="8100000" algn="bl" rotWithShape="0">
               <a:srgbClr val="000000">
                 <a:alpha val="10000"/>
               </a:srgbClr>
             </a:outerShdw>
           </a:effectLst>
         </p:spPr>
+        <p:txBody>
+          <a:bodyPr/>
+          <a:lstStyle/>
+          <a:p>
+            <a:endParaRPr lang="en-US"/>
+          </a:p>
+        </p:txBody>
       </p:sp>
       <p:sp>
         <p:nvSpPr>
@@ -4598,6 +4619,13 @@
           </a:solidFill>
           <a:ln/>
         </p:spPr>
+        <p:txBody>
+          <a:bodyPr/>
+          <a:lstStyle/>
+          <a:p>
+            <a:endParaRPr lang="en-US"/>
+          </a:p>
+        </p:txBody>
       </p:sp>
       <p:sp>
         <p:nvSpPr>
@@ -4623,17 +4651,24 @@
             <a:prstDash val="solid"/>
           </a:ln>
         </p:spPr>
+        <p:txBody>
+          <a:bodyPr/>
+          <a:lstStyle/>
+          <a:p>
+            <a:endParaRPr lang="en-US"/>
+          </a:p>
+        </p:txBody>
       </p:sp>
       <p:pic>
         <p:nvPicPr>
-          <p:cNvPr id="10" name="Image 0" descr="preencoded.png">    </p:cNvPr>
+          <p:cNvPr id="10" name="Image 0" descr="preencoded.png"/>
           <p:cNvPicPr>
             <a:picLocks noChangeAspect="1"/>
           </p:cNvPicPr>
           <p:nvPr/>
         </p:nvPicPr>
         <p:blipFill>
-          <a:blip r:embed="rId1"/>
+          <a:blip r:embed="rId3"/>
           <a:stretch>
             <a:fillRect/>
           </a:stretch>
@@ -4669,7 +4704,7 @@
           <a:bodyPr wrap="square" lIns="0" tIns="0" rIns="0" bIns="0" rtlCol="0" anchor="ctr"/>
           <a:lstStyle/>
           <a:p>
-            <a:pPr algn="l" indent="0" marL="0">
+            <a:pPr marL="0" indent="0" algn="l">
               <a:buNone/>
             </a:pPr>
             <a:r>
@@ -4708,7 +4743,7 @@
           <a:bodyPr wrap="square" rtlCol="0" anchor="t"/>
           <a:lstStyle/>
           <a:p>
-            <a:pPr algn="l" indent="0" marL="0">
+            <a:pPr marL="0" indent="0" algn="l">
               <a:buNone/>
             </a:pPr>
             <a:r>
@@ -4750,13 +4785,20 @@
             <a:prstDash val="solid"/>
           </a:ln>
           <a:effectLst>
-            <a:outerShdw sx="100000" sy="100000" kx="0" ky="0" algn="bl" rotWithShape="0" blurRad="101600" dist="25400" dir="8100000">
+            <a:outerShdw blurRad="101600" dist="25400" dir="8100000" algn="bl" rotWithShape="0">
               <a:srgbClr val="000000">
                 <a:alpha val="10000"/>
               </a:srgbClr>
             </a:outerShdw>
           </a:effectLst>
         </p:spPr>
+        <p:txBody>
+          <a:bodyPr/>
+          <a:lstStyle/>
+          <a:p>
+            <a:endParaRPr lang="en-US"/>
+          </a:p>
+        </p:txBody>
       </p:sp>
       <p:sp>
         <p:nvSpPr>
@@ -4777,6 +4819,13 @@
           </a:solidFill>
           <a:ln/>
         </p:spPr>
+        <p:txBody>
+          <a:bodyPr/>
+          <a:lstStyle/>
+          <a:p>
+            <a:endParaRPr lang="en-US"/>
+          </a:p>
+        </p:txBody>
       </p:sp>
       <p:sp>
         <p:nvSpPr>
@@ -4802,17 +4851,24 @@
             <a:prstDash val="solid"/>
           </a:ln>
         </p:spPr>
+        <p:txBody>
+          <a:bodyPr/>
+          <a:lstStyle/>
+          <a:p>
+            <a:endParaRPr lang="en-US"/>
+          </a:p>
+        </p:txBody>
       </p:sp>
       <p:pic>
         <p:nvPicPr>
-          <p:cNvPr id="16" name="Image 1" descr="preencoded.png">    </p:cNvPr>
+          <p:cNvPr id="16" name="Image 1" descr="preencoded.png"/>
           <p:cNvPicPr>
             <a:picLocks noChangeAspect="1"/>
           </p:cNvPicPr>
           <p:nvPr/>
         </p:nvPicPr>
         <p:blipFill>
-          <a:blip r:embed="rId2"/>
+          <a:blip r:embed="rId4"/>
           <a:stretch>
             <a:fillRect/>
           </a:stretch>
@@ -4848,7 +4904,7 @@
           <a:bodyPr wrap="square" lIns="0" tIns="0" rIns="0" bIns="0" rtlCol="0" anchor="ctr"/>
           <a:lstStyle/>
           <a:p>
-            <a:pPr algn="l" indent="0" marL="0">
+            <a:pPr marL="0" indent="0" algn="l">
               <a:buNone/>
             </a:pPr>
             <a:r>
@@ -4887,7 +4943,7 @@
           <a:bodyPr wrap="square" rtlCol="0" anchor="t"/>
           <a:lstStyle/>
           <a:p>
-            <a:pPr algn="l" indent="0" marL="0">
+            <a:pPr marL="0" indent="0" algn="l">
               <a:buNone/>
             </a:pPr>
             <a:r>
@@ -4929,13 +4985,20 @@
             <a:prstDash val="solid"/>
           </a:ln>
           <a:effectLst>
-            <a:outerShdw sx="100000" sy="100000" kx="0" ky="0" algn="bl" rotWithShape="0" blurRad="101600" dist="25400" dir="8100000">
+            <a:outerShdw blurRad="101600" dist="25400" dir="8100000" algn="bl" rotWithShape="0">
               <a:srgbClr val="000000">
                 <a:alpha val="10000"/>
               </a:srgbClr>
             </a:outerShdw>
           </a:effectLst>
         </p:spPr>
+        <p:txBody>
+          <a:bodyPr/>
+          <a:lstStyle/>
+          <a:p>
+            <a:endParaRPr lang="en-US"/>
+          </a:p>
+        </p:txBody>
       </p:sp>
       <p:sp>
         <p:nvSpPr>
@@ -4956,6 +5019,13 @@
           </a:solidFill>
           <a:ln/>
         </p:spPr>
+        <p:txBody>
+          <a:bodyPr/>
+          <a:lstStyle/>
+          <a:p>
+            <a:endParaRPr lang="en-US"/>
+          </a:p>
+        </p:txBody>
       </p:sp>
       <p:sp>
         <p:nvSpPr>
@@ -4981,17 +5051,24 @@
             <a:prstDash val="solid"/>
           </a:ln>
         </p:spPr>
+        <p:txBody>
+          <a:bodyPr/>
+          <a:lstStyle/>
+          <a:p>
+            <a:endParaRPr lang="en-US"/>
+          </a:p>
+        </p:txBody>
       </p:sp>
       <p:pic>
         <p:nvPicPr>
-          <p:cNvPr id="22" name="Image 2" descr="preencoded.png">    </p:cNvPr>
+          <p:cNvPr id="22" name="Image 2" descr="preencoded.png"/>
           <p:cNvPicPr>
             <a:picLocks noChangeAspect="1"/>
           </p:cNvPicPr>
           <p:nvPr/>
         </p:nvPicPr>
         <p:blipFill>
-          <a:blip r:embed="rId3"/>
+          <a:blip r:embed="rId5"/>
           <a:stretch>
             <a:fillRect/>
           </a:stretch>
@@ -5027,7 +5104,7 @@
           <a:bodyPr wrap="square" lIns="0" tIns="0" rIns="0" bIns="0" rtlCol="0" anchor="ctr"/>
           <a:lstStyle/>
           <a:p>
-            <a:pPr algn="l" indent="0" marL="0">
+            <a:pPr marL="0" indent="0" algn="l">
               <a:buNone/>
             </a:pPr>
             <a:r>
@@ -5066,7 +5143,7 @@
           <a:bodyPr wrap="square" rtlCol="0" anchor="t"/>
           <a:lstStyle/>
           <a:p>
-            <a:pPr algn="l" indent="0" marL="0">
+            <a:pPr marL="0" indent="0" algn="l">
               <a:buNone/>
             </a:pPr>
             <a:r>
@@ -5108,13 +5185,20 @@
             <a:prstDash val="solid"/>
           </a:ln>
           <a:effectLst>
-            <a:outerShdw sx="100000" sy="100000" kx="0" ky="0" algn="bl" rotWithShape="0" blurRad="101600" dist="25400" dir="8100000">
+            <a:outerShdw blurRad="101600" dist="25400" dir="8100000" algn="bl" rotWithShape="0">
               <a:srgbClr val="000000">
                 <a:alpha val="10000"/>
               </a:srgbClr>
             </a:outerShdw>
           </a:effectLst>
         </p:spPr>
+        <p:txBody>
+          <a:bodyPr/>
+          <a:lstStyle/>
+          <a:p>
+            <a:endParaRPr lang="en-US"/>
+          </a:p>
+        </p:txBody>
       </p:sp>
       <p:sp>
         <p:nvSpPr>
@@ -5135,6 +5219,13 @@
           </a:solidFill>
           <a:ln/>
         </p:spPr>
+        <p:txBody>
+          <a:bodyPr/>
+          <a:lstStyle/>
+          <a:p>
+            <a:endParaRPr lang="en-US"/>
+          </a:p>
+        </p:txBody>
       </p:sp>
       <p:sp>
         <p:nvSpPr>
@@ -5160,17 +5251,24 @@
             <a:prstDash val="solid"/>
           </a:ln>
         </p:spPr>
+        <p:txBody>
+          <a:bodyPr/>
+          <a:lstStyle/>
+          <a:p>
+            <a:endParaRPr lang="en-US"/>
+          </a:p>
+        </p:txBody>
       </p:sp>
       <p:pic>
         <p:nvPicPr>
-          <p:cNvPr id="28" name="Image 3" descr="preencoded.png">    </p:cNvPr>
+          <p:cNvPr id="28" name="Image 3" descr="preencoded.png"/>
           <p:cNvPicPr>
             <a:picLocks noChangeAspect="1"/>
           </p:cNvPicPr>
           <p:nvPr/>
         </p:nvPicPr>
         <p:blipFill>
-          <a:blip r:embed="rId4"/>
+          <a:blip r:embed="rId6"/>
           <a:stretch>
             <a:fillRect/>
           </a:stretch>
@@ -5206,7 +5304,7 @@
           <a:bodyPr wrap="square" lIns="0" tIns="0" rIns="0" bIns="0" rtlCol="0" anchor="ctr"/>
           <a:lstStyle/>
           <a:p>
-            <a:pPr algn="l" indent="0" marL="0">
+            <a:pPr marL="0" indent="0" algn="l">
               <a:buNone/>
             </a:pPr>
             <a:r>
@@ -5245,7 +5343,7 @@
           <a:bodyPr wrap="square" rtlCol="0" anchor="t"/>
           <a:lstStyle/>
           <a:p>
-            <a:pPr algn="l" indent="0" marL="0">
+            <a:pPr marL="0" indent="0" algn="l">
               <a:buNone/>
             </a:pPr>
             <a:r>
@@ -5279,6 +5377,7 @@
         <a:solidFill>
           <a:srgbClr val="0A2342"/>
         </a:solidFill>
+        <a:effectLst/>
       </p:bgPr>
     </p:bg>
     <p:spTree>
@@ -5314,6 +5413,13 @@
           </a:solidFill>
           <a:ln/>
         </p:spPr>
+        <p:txBody>
+          <a:bodyPr/>
+          <a:lstStyle/>
+          <a:p>
+            <a:endParaRPr lang="en-US"/>
+          </a:p>
+        </p:txBody>
       </p:sp>
       <p:sp>
         <p:nvSpPr>
@@ -5336,6 +5442,13 @@
           </a:solidFill>
           <a:ln/>
         </p:spPr>
+        <p:txBody>
+          <a:bodyPr/>
+          <a:lstStyle/>
+          <a:p>
+            <a:endParaRPr lang="en-US"/>
+          </a:p>
+        </p:txBody>
       </p:sp>
       <p:sp>
         <p:nvSpPr>
@@ -5358,7 +5471,7 @@
           <a:bodyPr wrap="square" lIns="0" tIns="0" rIns="0" bIns="0" rtlCol="0" anchor="ctr"/>
           <a:lstStyle/>
           <a:p>
-            <a:pPr algn="l" indent="0" marL="0">
+            <a:pPr marL="0" indent="0" algn="l">
               <a:buNone/>
             </a:pPr>
             <a:r>
@@ -5397,7 +5510,7 @@
           <a:bodyPr wrap="square" lIns="0" tIns="0" rIns="0" bIns="0" rtlCol="0" anchor="ctr"/>
           <a:lstStyle/>
           <a:p>
-            <a:pPr algn="l" indent="0" marL="0">
+            <a:pPr marL="0" indent="0" algn="l">
               <a:buNone/>
             </a:pPr>
             <a:r>
@@ -5439,13 +5552,20 @@
             <a:prstDash val="solid"/>
           </a:ln>
           <a:effectLst>
-            <a:outerShdw sx="100000" sy="100000" kx="0" ky="0" algn="bl" rotWithShape="0" blurRad="101600" dist="25400" dir="8100000">
+            <a:outerShdw blurRad="101600" dist="25400" dir="8100000" algn="bl" rotWithShape="0">
               <a:srgbClr val="000000">
                 <a:alpha val="10000"/>
               </a:srgbClr>
             </a:outerShdw>
           </a:effectLst>
         </p:spPr>
+        <p:txBody>
+          <a:bodyPr/>
+          <a:lstStyle/>
+          <a:p>
+            <a:endParaRPr lang="en-US"/>
+          </a:p>
+        </p:txBody>
       </p:sp>
       <p:sp>
         <p:nvSpPr>
@@ -5466,17 +5586,24 @@
           </a:solidFill>
           <a:ln/>
         </p:spPr>
+        <p:txBody>
+          <a:bodyPr/>
+          <a:lstStyle/>
+          <a:p>
+            <a:endParaRPr lang="en-US"/>
+          </a:p>
+        </p:txBody>
       </p:sp>
       <p:pic>
         <p:nvPicPr>
-          <p:cNvPr id="8" name="Image 0" descr="preencoded.png">    </p:cNvPr>
+          <p:cNvPr id="8" name="Image 0" descr="preencoded.png"/>
           <p:cNvPicPr>
             <a:picLocks noChangeAspect="1"/>
           </p:cNvPicPr>
           <p:nvPr/>
         </p:nvPicPr>
         <p:blipFill>
-          <a:blip r:embed="rId1"/>
+          <a:blip r:embed="rId3"/>
           <a:stretch>
             <a:fillRect/>
           </a:stretch>
@@ -5512,7 +5639,7 @@
           <a:bodyPr wrap="square" lIns="0" tIns="0" rIns="0" bIns="0" rtlCol="0" anchor="ctr"/>
           <a:lstStyle/>
           <a:p>
-            <a:pPr algn="l" indent="0" marL="0">
+            <a:pPr marL="0" indent="0" algn="l">
               <a:buNone/>
             </a:pPr>
             <a:r>
@@ -5551,7 +5678,7 @@
           <a:bodyPr wrap="square" rtlCol="0" anchor="t"/>
           <a:lstStyle/>
           <a:p>
-            <a:pPr algn="l" indent="0" marL="0">
+            <a:pPr marL="0" indent="0" algn="l">
               <a:buNone/>
             </a:pPr>
             <a:r>
@@ -5593,13 +5720,20 @@
             <a:prstDash val="solid"/>
           </a:ln>
           <a:effectLst>
-            <a:outerShdw sx="100000" sy="100000" kx="0" ky="0" algn="bl" rotWithShape="0" blurRad="101600" dist="25400" dir="8100000">
+            <a:outerShdw blurRad="101600" dist="25400" dir="8100000" algn="bl" rotWithShape="0">
               <a:srgbClr val="000000">
                 <a:alpha val="10000"/>
               </a:srgbClr>
             </a:outerShdw>
           </a:effectLst>
         </p:spPr>
+        <p:txBody>
+          <a:bodyPr/>
+          <a:lstStyle/>
+          <a:p>
+            <a:endParaRPr lang="en-US"/>
+          </a:p>
+        </p:txBody>
       </p:sp>
       <p:sp>
         <p:nvSpPr>
@@ -5620,17 +5754,24 @@
           </a:solidFill>
           <a:ln/>
         </p:spPr>
+        <p:txBody>
+          <a:bodyPr/>
+          <a:lstStyle/>
+          <a:p>
+            <a:endParaRPr lang="en-US"/>
+          </a:p>
+        </p:txBody>
       </p:sp>
       <p:pic>
         <p:nvPicPr>
-          <p:cNvPr id="13" name="Image 1" descr="preencoded.png">    </p:cNvPr>
+          <p:cNvPr id="13" name="Image 1" descr="preencoded.png"/>
           <p:cNvPicPr>
             <a:picLocks noChangeAspect="1"/>
           </p:cNvPicPr>
           <p:nvPr/>
         </p:nvPicPr>
         <p:blipFill>
-          <a:blip r:embed="rId2"/>
+          <a:blip r:embed="rId4"/>
           <a:stretch>
             <a:fillRect/>
           </a:stretch>
@@ -5666,7 +5807,7 @@
           <a:bodyPr wrap="square" lIns="0" tIns="0" rIns="0" bIns="0" rtlCol="0" anchor="ctr"/>
           <a:lstStyle/>
           <a:p>
-            <a:pPr algn="l" indent="0" marL="0">
+            <a:pPr marL="0" indent="0" algn="l">
               <a:buNone/>
             </a:pPr>
             <a:r>
@@ -5705,7 +5846,7 @@
           <a:bodyPr wrap="square" rtlCol="0" anchor="t"/>
           <a:lstStyle/>
           <a:p>
-            <a:pPr algn="l" indent="0" marL="0">
+            <a:pPr marL="0" indent="0" algn="l">
               <a:buNone/>
             </a:pPr>
             <a:r>
@@ -5747,13 +5888,20 @@
             <a:prstDash val="solid"/>
           </a:ln>
           <a:effectLst>
-            <a:outerShdw sx="100000" sy="100000" kx="0" ky="0" algn="bl" rotWithShape="0" blurRad="101600" dist="25400" dir="8100000">
+            <a:outerShdw blurRad="101600" dist="25400" dir="8100000" algn="bl" rotWithShape="0">
               <a:srgbClr val="000000">
                 <a:alpha val="10000"/>
               </a:srgbClr>
             </a:outerShdw>
           </a:effectLst>
         </p:spPr>
+        <p:txBody>
+          <a:bodyPr/>
+          <a:lstStyle/>
+          <a:p>
+            <a:endParaRPr lang="en-US"/>
+          </a:p>
+        </p:txBody>
       </p:sp>
       <p:sp>
         <p:nvSpPr>
@@ -5774,17 +5922,24 @@
           </a:solidFill>
           <a:ln/>
         </p:spPr>
+        <p:txBody>
+          <a:bodyPr/>
+          <a:lstStyle/>
+          <a:p>
+            <a:endParaRPr lang="en-US"/>
+          </a:p>
+        </p:txBody>
       </p:sp>
       <p:pic>
         <p:nvPicPr>
-          <p:cNvPr id="18" name="Image 2" descr="preencoded.png">    </p:cNvPr>
+          <p:cNvPr id="18" name="Image 2" descr="preencoded.png"/>
           <p:cNvPicPr>
             <a:picLocks noChangeAspect="1"/>
           </p:cNvPicPr>
           <p:nvPr/>
         </p:nvPicPr>
         <p:blipFill>
-          <a:blip r:embed="rId3"/>
+          <a:blip r:embed="rId5"/>
           <a:stretch>
             <a:fillRect/>
           </a:stretch>
@@ -5820,7 +5975,7 @@
           <a:bodyPr wrap="square" lIns="0" tIns="0" rIns="0" bIns="0" rtlCol="0" anchor="ctr"/>
           <a:lstStyle/>
           <a:p>
-            <a:pPr algn="l" indent="0" marL="0">
+            <a:pPr marL="0" indent="0" algn="l">
               <a:buNone/>
             </a:pPr>
             <a:r>
@@ -5859,7 +6014,7 @@
           <a:bodyPr wrap="square" rtlCol="0" anchor="t"/>
           <a:lstStyle/>
           <a:p>
-            <a:pPr algn="l" indent="0" marL="0">
+            <a:pPr marL="0" indent="0" algn="l">
               <a:buNone/>
             </a:pPr>
             <a:r>
@@ -5901,13 +6056,20 @@
             <a:prstDash val="solid"/>
           </a:ln>
           <a:effectLst>
-            <a:outerShdw sx="100000" sy="100000" kx="0" ky="0" algn="bl" rotWithShape="0" blurRad="101600" dist="25400" dir="8100000">
+            <a:outerShdw blurRad="101600" dist="25400" dir="8100000" algn="bl" rotWithShape="0">
               <a:srgbClr val="000000">
                 <a:alpha val="10000"/>
               </a:srgbClr>
             </a:outerShdw>
           </a:effectLst>
         </p:spPr>
+        <p:txBody>
+          <a:bodyPr/>
+          <a:lstStyle/>
+          <a:p>
+            <a:endParaRPr lang="en-US"/>
+          </a:p>
+        </p:txBody>
       </p:sp>
       <p:sp>
         <p:nvSpPr>
@@ -5928,17 +6090,24 @@
           </a:solidFill>
           <a:ln/>
         </p:spPr>
+        <p:txBody>
+          <a:bodyPr/>
+          <a:lstStyle/>
+          <a:p>
+            <a:endParaRPr lang="en-US"/>
+          </a:p>
+        </p:txBody>
       </p:sp>
       <p:pic>
         <p:nvPicPr>
-          <p:cNvPr id="23" name="Image 3" descr="preencoded.png">    </p:cNvPr>
+          <p:cNvPr id="23" name="Image 3" descr="preencoded.png"/>
           <p:cNvPicPr>
             <a:picLocks noChangeAspect="1"/>
           </p:cNvPicPr>
           <p:nvPr/>
         </p:nvPicPr>
         <p:blipFill>
-          <a:blip r:embed="rId4"/>
+          <a:blip r:embed="rId6"/>
           <a:stretch>
             <a:fillRect/>
           </a:stretch>
@@ -5974,7 +6143,7 @@
           <a:bodyPr wrap="square" lIns="0" tIns="0" rIns="0" bIns="0" rtlCol="0" anchor="ctr"/>
           <a:lstStyle/>
           <a:p>
-            <a:pPr algn="l" indent="0" marL="0">
+            <a:pPr marL="0" indent="0" algn="l">
               <a:buNone/>
             </a:pPr>
             <a:r>
@@ -6013,7 +6182,7 @@
           <a:bodyPr wrap="square" rtlCol="0" anchor="t"/>
           <a:lstStyle/>
           <a:p>
-            <a:pPr algn="l" indent="0" marL="0">
+            <a:pPr marL="0" indent="0" algn="l">
               <a:buNone/>
             </a:pPr>
             <a:r>
@@ -6055,13 +6224,20 @@
             <a:prstDash val="solid"/>
           </a:ln>
           <a:effectLst>
-            <a:outerShdw sx="100000" sy="100000" kx="0" ky="0" algn="bl" rotWithShape="0" blurRad="101600" dist="25400" dir="8100000">
+            <a:outerShdw blurRad="101600" dist="25400" dir="8100000" algn="bl" rotWithShape="0">
               <a:srgbClr val="000000">
                 <a:alpha val="10000"/>
               </a:srgbClr>
             </a:outerShdw>
           </a:effectLst>
         </p:spPr>
+        <p:txBody>
+          <a:bodyPr/>
+          <a:lstStyle/>
+          <a:p>
+            <a:endParaRPr lang="en-US"/>
+          </a:p>
+        </p:txBody>
       </p:sp>
       <p:sp>
         <p:nvSpPr>
@@ -6082,17 +6258,24 @@
           </a:solidFill>
           <a:ln/>
         </p:spPr>
+        <p:txBody>
+          <a:bodyPr/>
+          <a:lstStyle/>
+          <a:p>
+            <a:endParaRPr lang="en-US"/>
+          </a:p>
+        </p:txBody>
       </p:sp>
       <p:pic>
         <p:nvPicPr>
-          <p:cNvPr id="28" name="Image 4" descr="preencoded.png">    </p:cNvPr>
+          <p:cNvPr id="28" name="Image 4" descr="preencoded.png"/>
           <p:cNvPicPr>
             <a:picLocks noChangeAspect="1"/>
           </p:cNvPicPr>
           <p:nvPr/>
         </p:nvPicPr>
         <p:blipFill>
-          <a:blip r:embed="rId5"/>
+          <a:blip r:embed="rId7"/>
           <a:stretch>
             <a:fillRect/>
           </a:stretch>
@@ -6128,7 +6311,7 @@
           <a:bodyPr wrap="square" lIns="0" tIns="0" rIns="0" bIns="0" rtlCol="0" anchor="ctr"/>
           <a:lstStyle/>
           <a:p>
-            <a:pPr algn="l" indent="0" marL="0">
+            <a:pPr marL="0" indent="0" algn="l">
               <a:buNone/>
             </a:pPr>
             <a:r>
@@ -6167,7 +6350,7 @@
           <a:bodyPr wrap="square" rtlCol="0" anchor="t"/>
           <a:lstStyle/>
           <a:p>
-            <a:pPr algn="l" indent="0" marL="0">
+            <a:pPr marL="0" indent="0" algn="l">
               <a:buNone/>
             </a:pPr>
             <a:r>
@@ -6209,13 +6392,20 @@
             <a:prstDash val="solid"/>
           </a:ln>
           <a:effectLst>
-            <a:outerShdw sx="100000" sy="100000" kx="0" ky="0" algn="bl" rotWithShape="0" blurRad="101600" dist="25400" dir="8100000">
+            <a:outerShdw blurRad="101600" dist="25400" dir="8100000" algn="bl" rotWithShape="0">
               <a:srgbClr val="000000">
                 <a:alpha val="10000"/>
               </a:srgbClr>
             </a:outerShdw>
           </a:effectLst>
         </p:spPr>
+        <p:txBody>
+          <a:bodyPr/>
+          <a:lstStyle/>
+          <a:p>
+            <a:endParaRPr lang="en-US"/>
+          </a:p>
+        </p:txBody>
       </p:sp>
       <p:sp>
         <p:nvSpPr>
@@ -6236,17 +6426,24 @@
           </a:solidFill>
           <a:ln/>
         </p:spPr>
+        <p:txBody>
+          <a:bodyPr/>
+          <a:lstStyle/>
+          <a:p>
+            <a:endParaRPr lang="en-US"/>
+          </a:p>
+        </p:txBody>
       </p:sp>
       <p:pic>
         <p:nvPicPr>
-          <p:cNvPr id="33" name="Image 5" descr="preencoded.png">    </p:cNvPr>
+          <p:cNvPr id="33" name="Image 5" descr="preencoded.png"/>
           <p:cNvPicPr>
             <a:picLocks noChangeAspect="1"/>
           </p:cNvPicPr>
           <p:nvPr/>
         </p:nvPicPr>
         <p:blipFill>
-          <a:blip r:embed="rId6"/>
+          <a:blip r:embed="rId8"/>
           <a:stretch>
             <a:fillRect/>
           </a:stretch>
@@ -6282,7 +6479,7 @@
           <a:bodyPr wrap="square" lIns="0" tIns="0" rIns="0" bIns="0" rtlCol="0" anchor="ctr"/>
           <a:lstStyle/>
           <a:p>
-            <a:pPr algn="l" indent="0" marL="0">
+            <a:pPr marL="0" indent="0" algn="l">
               <a:buNone/>
             </a:pPr>
             <a:r>
@@ -6321,7 +6518,7 @@
           <a:bodyPr wrap="square" rtlCol="0" anchor="t"/>
           <a:lstStyle/>
           <a:p>
-            <a:pPr algn="l" indent="0" marL="0">
+            <a:pPr marL="0" indent="0" algn="l">
               <a:buNone/>
             </a:pPr>
             <a:r>
@@ -6355,6 +6552,7 @@
         <a:solidFill>
           <a:srgbClr val="F0F4F8"/>
         </a:solidFill>
+        <a:effectLst/>
       </p:bgPr>
     </p:bg>
     <p:spTree>
@@ -6392,7 +6590,7 @@
           <a:bodyPr wrap="square" lIns="0" tIns="0" rIns="0" bIns="0" rtlCol="0" anchor="ctr"/>
           <a:lstStyle/>
           <a:p>
-            <a:pPr algn="l" indent="0" marL="0">
+            <a:pPr marL="0" indent="0" algn="l">
               <a:buNone/>
             </a:pPr>
             <a:r>
@@ -6431,7 +6629,7 @@
           <a:bodyPr wrap="square" lIns="0" tIns="0" rIns="0" bIns="0" rtlCol="0" anchor="ctr"/>
           <a:lstStyle/>
           <a:p>
-            <a:pPr algn="l" indent="0" marL="0">
+            <a:pPr marL="0" indent="0" algn="l">
               <a:buNone/>
             </a:pPr>
             <a:r>
@@ -6468,6 +6666,13 @@
           </a:solidFill>
           <a:ln/>
         </p:spPr>
+        <p:txBody>
+          <a:bodyPr/>
+          <a:lstStyle/>
+          <a:p>
+            <a:endParaRPr lang="en-US"/>
+          </a:p>
+        </p:txBody>
       </p:sp>
       <p:sp>
         <p:nvSpPr>
@@ -6490,11 +6695,11 @@
           <a:bodyPr wrap="square" lIns="0" tIns="0" rIns="0" bIns="0" rtlCol="0" anchor="ctr"/>
           <a:lstStyle/>
           <a:p>
-            <a:pPr indent="0" marL="0">
-              <a:buNone/>
-            </a:pPr>
-            <a:r>
-              <a:rPr lang="en-US" sz="900" b="1" spc="150" kern="0" dirty="0">
+            <a:pPr marL="0" indent="0">
+              <a:buNone/>
+            </a:pPr>
+            <a:r>
+              <a:rPr lang="en-US" sz="900" b="1" kern="0" spc="150" dirty="0">
                 <a:solidFill>
                   <a:srgbClr val="065A82"/>
                 </a:solidFill>
@@ -6532,13 +6737,20 @@
             <a:prstDash val="solid"/>
           </a:ln>
           <a:effectLst>
-            <a:outerShdw sx="100000" sy="100000" kx="0" ky="0" algn="bl" rotWithShape="0" blurRad="101600" dist="25400" dir="8100000">
+            <a:outerShdw blurRad="101600" dist="25400" dir="8100000" algn="bl" rotWithShape="0">
               <a:srgbClr val="000000">
                 <a:alpha val="10000"/>
               </a:srgbClr>
             </a:outerShdw>
           </a:effectLst>
         </p:spPr>
+        <p:txBody>
+          <a:bodyPr/>
+          <a:lstStyle/>
+          <a:p>
+            <a:endParaRPr lang="en-US"/>
+          </a:p>
+        </p:txBody>
       </p:sp>
       <p:sp>
         <p:nvSpPr>
@@ -6559,17 +6771,24 @@
           </a:solidFill>
           <a:ln/>
         </p:spPr>
+        <p:txBody>
+          <a:bodyPr/>
+          <a:lstStyle/>
+          <a:p>
+            <a:endParaRPr lang="en-US"/>
+          </a:p>
+        </p:txBody>
       </p:sp>
       <p:pic>
         <p:nvPicPr>
-          <p:cNvPr id="8" name="Image 0" descr="preencoded.png">    </p:cNvPr>
+          <p:cNvPr id="8" name="Image 0" descr="preencoded.png"/>
           <p:cNvPicPr>
             <a:picLocks noChangeAspect="1"/>
           </p:cNvPicPr>
           <p:nvPr/>
         </p:nvPicPr>
         <p:blipFill>
-          <a:blip r:embed="rId1"/>
+          <a:blip r:embed="rId3"/>
           <a:stretch>
             <a:fillRect/>
           </a:stretch>
@@ -6605,7 +6824,7 @@
           <a:bodyPr wrap="square" rtlCol="0" anchor="ctr"/>
           <a:lstStyle/>
           <a:p>
-            <a:pPr algn="l" indent="0" marL="0">
+            <a:pPr marL="0" indent="0" algn="l">
               <a:buNone/>
             </a:pPr>
             <a:r>
@@ -6622,7 +6841,7 @@
             <a:endParaRPr lang="en-US" sz="1100" dirty="0"/>
           </a:p>
           <a:p>
-            <a:pPr algn="l" indent="0" marL="0">
+            <a:pPr marL="0" indent="0" algn="l">
               <a:buNone/>
             </a:pPr>
             <a:r>
@@ -6661,7 +6880,7 @@
           <a:bodyPr wrap="square" rtlCol="0" anchor="t"/>
           <a:lstStyle/>
           <a:p>
-            <a:pPr algn="l" indent="0" marL="0">
+            <a:pPr marL="0" indent="0" algn="l">
               <a:buNone/>
             </a:pPr>
             <a:r>
@@ -6678,7 +6897,7 @@
             <a:endParaRPr lang="en-US" sz="1000" dirty="0"/>
           </a:p>
           <a:p>
-            <a:pPr algn="l" indent="0" marL="0">
+            <a:pPr marL="0" indent="0" algn="l">
               <a:buNone/>
             </a:pPr>
             <a:r>
@@ -6717,7 +6936,7 @@
           <a:bodyPr wrap="square" lIns="0" tIns="0" rIns="0" bIns="0" rtlCol="0" anchor="ctr"/>
           <a:lstStyle/>
           <a:p>
-            <a:pPr algn="ctr" indent="0" marL="0">
+            <a:pPr marL="0" indent="0" algn="ctr">
               <a:buNone/>
             </a:pPr>
             <a:r>
@@ -6756,13 +6975,20 @@
             <a:prstDash val="solid"/>
           </a:ln>
           <a:effectLst>
-            <a:outerShdw sx="100000" sy="100000" kx="0" ky="0" algn="bl" rotWithShape="0" blurRad="101600" dist="25400" dir="8100000">
+            <a:outerShdw blurRad="101600" dist="25400" dir="8100000" algn="bl" rotWithShape="0">
               <a:srgbClr val="000000">
                 <a:alpha val="10000"/>
               </a:srgbClr>
             </a:outerShdw>
           </a:effectLst>
         </p:spPr>
+        <p:txBody>
+          <a:bodyPr/>
+          <a:lstStyle/>
+          <a:p>
+            <a:endParaRPr lang="en-US"/>
+          </a:p>
+        </p:txBody>
       </p:sp>
       <p:sp>
         <p:nvSpPr>
@@ -6783,17 +7009,24 @@
           </a:solidFill>
           <a:ln/>
         </p:spPr>
+        <p:txBody>
+          <a:bodyPr/>
+          <a:lstStyle/>
+          <a:p>
+            <a:endParaRPr lang="en-US"/>
+          </a:p>
+        </p:txBody>
       </p:sp>
       <p:pic>
         <p:nvPicPr>
-          <p:cNvPr id="14" name="Image 1" descr="preencoded.png">    </p:cNvPr>
+          <p:cNvPr id="14" name="Image 1" descr="preencoded.png"/>
           <p:cNvPicPr>
             <a:picLocks noChangeAspect="1"/>
           </p:cNvPicPr>
           <p:nvPr/>
         </p:nvPicPr>
         <p:blipFill>
-          <a:blip r:embed="rId2"/>
+          <a:blip r:embed="rId4"/>
           <a:stretch>
             <a:fillRect/>
           </a:stretch>
@@ -6829,7 +7062,7 @@
           <a:bodyPr wrap="square" rtlCol="0" anchor="ctr"/>
           <a:lstStyle/>
           <a:p>
-            <a:pPr algn="l" indent="0" marL="0">
+            <a:pPr marL="0" indent="0" algn="l">
               <a:buNone/>
             </a:pPr>
             <a:r>
@@ -6846,7 +7079,7 @@
             <a:endParaRPr lang="en-US" sz="1100" dirty="0"/>
           </a:p>
           <a:p>
-            <a:pPr algn="l" indent="0" marL="0">
+            <a:pPr marL="0" indent="0" algn="l">
               <a:buNone/>
             </a:pPr>
             <a:r>
@@ -6885,7 +7118,7 @@
           <a:bodyPr wrap="square" rtlCol="0" anchor="t"/>
           <a:lstStyle/>
           <a:p>
-            <a:pPr algn="l" indent="0" marL="0">
+            <a:pPr marL="0" indent="0" algn="l">
               <a:buNone/>
             </a:pPr>
             <a:r>
@@ -6902,7 +7135,7 @@
             <a:endParaRPr lang="en-US" sz="1000" dirty="0"/>
           </a:p>
           <a:p>
-            <a:pPr algn="l" indent="0" marL="0">
+            <a:pPr marL="0" indent="0" algn="l">
               <a:buNone/>
             </a:pPr>
             <a:r>
@@ -6941,7 +7174,7 @@
           <a:bodyPr wrap="square" lIns="0" tIns="0" rIns="0" bIns="0" rtlCol="0" anchor="ctr"/>
           <a:lstStyle/>
           <a:p>
-            <a:pPr algn="ctr" indent="0" marL="0">
+            <a:pPr marL="0" indent="0" algn="ctr">
               <a:buNone/>
             </a:pPr>
             <a:r>
@@ -6980,13 +7213,20 @@
             <a:prstDash val="solid"/>
           </a:ln>
           <a:effectLst>
-            <a:outerShdw sx="100000" sy="100000" kx="0" ky="0" algn="bl" rotWithShape="0" blurRad="101600" dist="25400" dir="8100000">
+            <a:outerShdw blurRad="101600" dist="25400" dir="8100000" algn="bl" rotWithShape="0">
               <a:srgbClr val="000000">
                 <a:alpha val="10000"/>
               </a:srgbClr>
             </a:outerShdw>
           </a:effectLst>
         </p:spPr>
+        <p:txBody>
+          <a:bodyPr/>
+          <a:lstStyle/>
+          <a:p>
+            <a:endParaRPr lang="en-US"/>
+          </a:p>
+        </p:txBody>
       </p:sp>
       <p:sp>
         <p:nvSpPr>
@@ -7007,17 +7247,24 @@
           </a:solidFill>
           <a:ln/>
         </p:spPr>
+        <p:txBody>
+          <a:bodyPr/>
+          <a:lstStyle/>
+          <a:p>
+            <a:endParaRPr lang="en-US"/>
+          </a:p>
+        </p:txBody>
       </p:sp>
       <p:pic>
         <p:nvPicPr>
-          <p:cNvPr id="20" name="Image 2" descr="preencoded.png">    </p:cNvPr>
+          <p:cNvPr id="20" name="Image 2" descr="preencoded.png"/>
           <p:cNvPicPr>
             <a:picLocks noChangeAspect="1"/>
           </p:cNvPicPr>
           <p:nvPr/>
         </p:nvPicPr>
         <p:blipFill>
-          <a:blip r:embed="rId3"/>
+          <a:blip r:embed="rId5"/>
           <a:stretch>
             <a:fillRect/>
           </a:stretch>
@@ -7053,7 +7300,7 @@
           <a:bodyPr wrap="square" rtlCol="0" anchor="ctr"/>
           <a:lstStyle/>
           <a:p>
-            <a:pPr algn="l" indent="0" marL="0">
+            <a:pPr marL="0" indent="0" algn="l">
               <a:buNone/>
             </a:pPr>
             <a:r>
@@ -7070,7 +7317,7 @@
             <a:endParaRPr lang="en-US" sz="1100" dirty="0"/>
           </a:p>
           <a:p>
-            <a:pPr algn="l" indent="0" marL="0">
+            <a:pPr marL="0" indent="0" algn="l">
               <a:buNone/>
             </a:pPr>
             <a:r>
@@ -7109,7 +7356,7 @@
           <a:bodyPr wrap="square" rtlCol="0" anchor="t"/>
           <a:lstStyle/>
           <a:p>
-            <a:pPr algn="l" indent="0" marL="0">
+            <a:pPr marL="0" indent="0" algn="l">
               <a:buNone/>
             </a:pPr>
             <a:r>
@@ -7126,7 +7373,7 @@
             <a:endParaRPr lang="en-US" sz="1000" dirty="0"/>
           </a:p>
           <a:p>
-            <a:pPr algn="l" indent="0" marL="0">
+            <a:pPr marL="0" indent="0" algn="l">
               <a:buNone/>
             </a:pPr>
             <a:r>
@@ -7165,7 +7412,7 @@
           <a:bodyPr wrap="square" lIns="0" tIns="0" rIns="0" bIns="0" rtlCol="0" anchor="ctr"/>
           <a:lstStyle/>
           <a:p>
-            <a:pPr algn="ctr" indent="0" marL="0">
+            <a:pPr marL="0" indent="0" algn="ctr">
               <a:buNone/>
             </a:pPr>
             <a:r>
@@ -7204,13 +7451,20 @@
             <a:prstDash val="solid"/>
           </a:ln>
           <a:effectLst>
-            <a:outerShdw sx="100000" sy="100000" kx="0" ky="0" algn="bl" rotWithShape="0" blurRad="101600" dist="25400" dir="8100000">
+            <a:outerShdw blurRad="101600" dist="25400" dir="8100000" algn="bl" rotWithShape="0">
               <a:srgbClr val="000000">
                 <a:alpha val="10000"/>
               </a:srgbClr>
             </a:outerShdw>
           </a:effectLst>
         </p:spPr>
+        <p:txBody>
+          <a:bodyPr/>
+          <a:lstStyle/>
+          <a:p>
+            <a:endParaRPr lang="en-US"/>
+          </a:p>
+        </p:txBody>
       </p:sp>
       <p:sp>
         <p:nvSpPr>
@@ -7231,17 +7485,24 @@
           </a:solidFill>
           <a:ln/>
         </p:spPr>
+        <p:txBody>
+          <a:bodyPr/>
+          <a:lstStyle/>
+          <a:p>
+            <a:endParaRPr lang="en-US"/>
+          </a:p>
+        </p:txBody>
       </p:sp>
       <p:pic>
         <p:nvPicPr>
-          <p:cNvPr id="26" name="Image 3" descr="preencoded.png">    </p:cNvPr>
+          <p:cNvPr id="26" name="Image 3" descr="preencoded.png"/>
           <p:cNvPicPr>
             <a:picLocks noChangeAspect="1"/>
           </p:cNvPicPr>
           <p:nvPr/>
         </p:nvPicPr>
         <p:blipFill>
-          <a:blip r:embed="rId4"/>
+          <a:blip r:embed="rId6"/>
           <a:stretch>
             <a:fillRect/>
           </a:stretch>
@@ -7277,7 +7538,7 @@
           <a:bodyPr wrap="square" rtlCol="0" anchor="ctr"/>
           <a:lstStyle/>
           <a:p>
-            <a:pPr algn="l" indent="0" marL="0">
+            <a:pPr marL="0" indent="0" algn="l">
               <a:buNone/>
             </a:pPr>
             <a:r>
@@ -7316,7 +7577,7 @@
           <a:bodyPr wrap="square" rtlCol="0" anchor="t"/>
           <a:lstStyle/>
           <a:p>
-            <a:pPr algn="l" indent="0" marL="0">
+            <a:pPr marL="0" indent="0" algn="l">
               <a:buNone/>
             </a:pPr>
             <a:r>
@@ -7333,7 +7594,7 @@
             <a:endParaRPr lang="en-US" sz="1000" dirty="0"/>
           </a:p>
           <a:p>
-            <a:pPr algn="l" indent="0" marL="0">
+            <a:pPr marL="0" indent="0" algn="l">
               <a:buNone/>
             </a:pPr>
             <a:r>
@@ -7370,6 +7631,13 @@
           </a:solidFill>
           <a:ln/>
         </p:spPr>
+        <p:txBody>
+          <a:bodyPr/>
+          <a:lstStyle/>
+          <a:p>
+            <a:endParaRPr lang="en-US"/>
+          </a:p>
+        </p:txBody>
       </p:sp>
       <p:sp>
         <p:nvSpPr>
@@ -7392,11 +7660,11 @@
           <a:bodyPr wrap="square" lIns="0" tIns="0" rIns="0" bIns="0" rtlCol="0" anchor="ctr"/>
           <a:lstStyle/>
           <a:p>
-            <a:pPr indent="0" marL="0">
-              <a:buNone/>
-            </a:pPr>
-            <a:r>
-              <a:rPr lang="en-US" sz="900" b="1" spc="150" kern="0" dirty="0">
+            <a:pPr marL="0" indent="0">
+              <a:buNone/>
+            </a:pPr>
+            <a:r>
+              <a:rPr lang="en-US" sz="900" b="1" kern="0" spc="150" dirty="0">
                 <a:solidFill>
                   <a:srgbClr val="1C7293"/>
                 </a:solidFill>
@@ -7434,13 +7702,20 @@
             <a:prstDash val="solid"/>
           </a:ln>
           <a:effectLst>
-            <a:outerShdw sx="100000" sy="100000" kx="0" ky="0" algn="bl" rotWithShape="0" blurRad="101600" dist="25400" dir="8100000">
+            <a:outerShdw blurRad="101600" dist="25400" dir="8100000" algn="bl" rotWithShape="0">
               <a:srgbClr val="000000">
                 <a:alpha val="10000"/>
               </a:srgbClr>
             </a:outerShdw>
           </a:effectLst>
         </p:spPr>
+        <p:txBody>
+          <a:bodyPr/>
+          <a:lstStyle/>
+          <a:p>
+            <a:endParaRPr lang="en-US"/>
+          </a:p>
+        </p:txBody>
       </p:sp>
       <p:sp>
         <p:nvSpPr>
@@ -7461,10 +7736,255 @@
           </a:solidFill>
           <a:ln/>
         </p:spPr>
+        <p:txBody>
+          <a:bodyPr/>
+          <a:lstStyle/>
+          <a:p>
+            <a:endParaRPr lang="en-US"/>
+          </a:p>
+        </p:txBody>
       </p:sp>
       <p:pic>
         <p:nvPicPr>
-          <p:cNvPr id="33" name="Image 4" descr="preencoded.png">    </p:cNvPr>
+          <p:cNvPr id="33" name="Image 4" descr="preencoded.png"/>
+          <p:cNvPicPr>
+            <a:picLocks noChangeAspect="1"/>
+          </p:cNvPicPr>
+          <p:nvPr/>
+        </p:nvPicPr>
+        <p:blipFill>
+          <a:blip r:embed="rId6"/>
+          <a:stretch>
+            <a:fillRect/>
+          </a:stretch>
+        </p:blipFill>
+        <p:spPr>
+          <a:xfrm>
+            <a:off x="411480" y="2953512"/>
+            <a:ext cx="201168" cy="201168"/>
+          </a:xfrm>
+          <a:prstGeom prst="rect">
+            <a:avLst/>
+          </a:prstGeom>
+        </p:spPr>
+      </p:pic>
+      <p:sp>
+        <p:nvSpPr>
+          <p:cNvPr id="34" name="Text 27"/>
+          <p:cNvSpPr/>
+          <p:nvPr/>
+        </p:nvSpPr>
+        <p:spPr>
+          <a:xfrm>
+            <a:off x="640080" y="2935224"/>
+            <a:ext cx="978408" cy="384048"/>
+          </a:xfrm>
+          <a:prstGeom prst="rect">
+            <a:avLst/>
+          </a:prstGeom>
+          <a:noFill/>
+          <a:ln/>
+        </p:spPr>
+        <p:txBody>
+          <a:bodyPr wrap="square" rtlCol="0" anchor="ctr"/>
+          <a:lstStyle/>
+          <a:p>
+            <a:pPr marL="0" indent="0" algn="l">
+              <a:buNone/>
+            </a:pPr>
+            <a:r>
+              <a:rPr lang="en-US" sz="1100" b="1" dirty="0">
+                <a:solidFill>
+                  <a:srgbClr val="1A2B3C"/>
+                </a:solidFill>
+                <a:latin typeface="Calibri" pitchFamily="34" charset="0"/>
+                <a:ea typeface="Calibri" pitchFamily="34" charset="-122"/>
+                <a:cs typeface="Calibri" pitchFamily="34" charset="-120"/>
+              </a:rPr>
+              <a:t>Poll</a:t>
+            </a:r>
+            <a:endParaRPr lang="en-US" sz="1100" dirty="0"/>
+          </a:p>
+          <a:p>
+            <a:pPr marL="0" indent="0" algn="l">
+              <a:buNone/>
+            </a:pPr>
+            <a:r>
+              <a:rPr lang="en-US" sz="1100" b="1" dirty="0">
+                <a:solidFill>
+                  <a:srgbClr val="1A2B3C"/>
+                </a:solidFill>
+                <a:latin typeface="Calibri" pitchFamily="34" charset="0"/>
+                <a:ea typeface="Calibri" pitchFamily="34" charset="-122"/>
+                <a:cs typeface="Calibri" pitchFamily="34" charset="-120"/>
+              </a:rPr>
+              <a:t>Queue</a:t>
+            </a:r>
+            <a:endParaRPr lang="en-US" sz="1100" dirty="0"/>
+          </a:p>
+        </p:txBody>
+      </p:sp>
+      <p:sp>
+        <p:nvSpPr>
+          <p:cNvPr id="35" name="Text 28"/>
+          <p:cNvSpPr/>
+          <p:nvPr/>
+        </p:nvSpPr>
+        <p:spPr>
+          <a:xfrm>
+            <a:off x="411480" y="3374136"/>
+            <a:ext cx="1252728" cy="502920"/>
+          </a:xfrm>
+          <a:prstGeom prst="rect">
+            <a:avLst/>
+          </a:prstGeom>
+          <a:noFill/>
+          <a:ln/>
+        </p:spPr>
+        <p:txBody>
+          <a:bodyPr wrap="square" rtlCol="0" anchor="t"/>
+          <a:lstStyle/>
+          <a:p>
+            <a:pPr marL="0" indent="0" algn="l">
+              <a:buNone/>
+            </a:pPr>
+            <a:r>
+              <a:rPr lang="en-US" sz="1000" dirty="0">
+                <a:solidFill>
+                  <a:srgbClr val="4A6080"/>
+                </a:solidFill>
+                <a:latin typeface="Calibri" pitchFamily="34" charset="0"/>
+                <a:ea typeface="Calibri" pitchFamily="34" charset="-122"/>
+                <a:cs typeface="Calibri" pitchFamily="34" charset="-120"/>
+              </a:rPr>
+              <a:t>UNRESOLVED rows</a:t>
+            </a:r>
+            <a:endParaRPr lang="en-US" sz="1000" dirty="0"/>
+          </a:p>
+          <a:p>
+            <a:pPr marL="0" indent="0" algn="l">
+              <a:buNone/>
+            </a:pPr>
+            <a:r>
+              <a:rPr lang="en-US" sz="1000" dirty="0">
+                <a:solidFill>
+                  <a:srgbClr val="4A6080"/>
+                </a:solidFill>
+                <a:latin typeface="Calibri" pitchFamily="34" charset="0"/>
+                <a:ea typeface="Calibri" pitchFamily="34" charset="-122"/>
+                <a:cs typeface="Calibri" pitchFamily="34" charset="-120"/>
+              </a:rPr>
+              <a:t>IR queue view</a:t>
+            </a:r>
+            <a:endParaRPr lang="en-US" sz="1000" dirty="0"/>
+          </a:p>
+        </p:txBody>
+      </p:sp>
+      <p:sp>
+        <p:nvSpPr>
+          <p:cNvPr id="36" name="Text 29"/>
+          <p:cNvSpPr/>
+          <p:nvPr/>
+        </p:nvSpPr>
+        <p:spPr>
+          <a:xfrm>
+            <a:off x="1746504" y="3209544"/>
+            <a:ext cx="201168" cy="274320"/>
+          </a:xfrm>
+          <a:prstGeom prst="rect">
+            <a:avLst/>
+          </a:prstGeom>
+          <a:noFill/>
+          <a:ln/>
+        </p:spPr>
+        <p:txBody>
+          <a:bodyPr wrap="square" lIns="0" tIns="0" rIns="0" bIns="0" rtlCol="0" anchor="ctr"/>
+          <a:lstStyle/>
+          <a:p>
+            <a:pPr marL="0" indent="0" algn="ctr">
+              <a:buNone/>
+            </a:pPr>
+            <a:r>
+              <a:rPr lang="en-US" sz="1100" dirty="0">
+                <a:solidFill>
+                  <a:srgbClr val="02C39A"/>
+                </a:solidFill>
+              </a:rPr>
+              <a:t>▶</a:t>
+            </a:r>
+            <a:endParaRPr lang="en-US" sz="1100" dirty="0"/>
+          </a:p>
+        </p:txBody>
+      </p:sp>
+      <p:sp>
+        <p:nvSpPr>
+          <p:cNvPr id="37" name="Shape 30"/>
+          <p:cNvSpPr/>
+          <p:nvPr/>
+        </p:nvSpPr>
+        <p:spPr>
+          <a:xfrm>
+            <a:off x="1965960" y="2862072"/>
+            <a:ext cx="1389888" cy="1078992"/>
+          </a:xfrm>
+          <a:prstGeom prst="rect">
+            <a:avLst/>
+          </a:prstGeom>
+          <a:solidFill>
+            <a:srgbClr val="FFFFFF"/>
+          </a:solidFill>
+          <a:ln w="12700">
+            <a:solidFill>
+              <a:srgbClr val="D0DDE8"/>
+            </a:solidFill>
+            <a:prstDash val="solid"/>
+          </a:ln>
+          <a:effectLst>
+            <a:outerShdw blurRad="101600" dist="25400" dir="8100000" algn="bl" rotWithShape="0">
+              <a:srgbClr val="000000">
+                <a:alpha val="10000"/>
+              </a:srgbClr>
+            </a:outerShdw>
+          </a:effectLst>
+        </p:spPr>
+        <p:txBody>
+          <a:bodyPr/>
+          <a:lstStyle/>
+          <a:p>
+            <a:endParaRPr lang="en-US"/>
+          </a:p>
+        </p:txBody>
+      </p:sp>
+      <p:sp>
+        <p:nvSpPr>
+          <p:cNvPr id="38" name="Shape 31"/>
+          <p:cNvSpPr/>
+          <p:nvPr/>
+        </p:nvSpPr>
+        <p:spPr>
+          <a:xfrm>
+            <a:off x="1965960" y="2862072"/>
+            <a:ext cx="1389888" cy="54864"/>
+          </a:xfrm>
+          <a:prstGeom prst="rect">
+            <a:avLst/>
+          </a:prstGeom>
+          <a:solidFill>
+            <a:srgbClr val="065A82"/>
+          </a:solidFill>
+          <a:ln/>
+        </p:spPr>
+        <p:txBody>
+          <a:bodyPr/>
+          <a:lstStyle/>
+          <a:p>
+            <a:endParaRPr lang="en-US"/>
+          </a:p>
+        </p:txBody>
+      </p:sp>
+      <p:pic>
+        <p:nvPicPr>
+          <p:cNvPr id="39" name="Image 5" descr="preencoded.png"/>
           <p:cNvPicPr>
             <a:picLocks noChangeAspect="1"/>
           </p:cNvPicPr>
@@ -7478,7 +7998,7 @@
         </p:blipFill>
         <p:spPr>
           <a:xfrm>
-            <a:off x="411480" y="2953512"/>
+            <a:off x="2057400" y="2953512"/>
             <a:ext cx="201168" cy="201168"/>
           </a:xfrm>
           <a:prstGeom prst="rect">
@@ -7488,13 +8008,13 @@
       </p:pic>
       <p:sp>
         <p:nvSpPr>
-          <p:cNvPr id="34" name="Text 27"/>
-          <p:cNvSpPr/>
-          <p:nvPr/>
-        </p:nvSpPr>
-        <p:spPr>
-          <a:xfrm>
-            <a:off x="640080" y="2935224"/>
+          <p:cNvPr id="40" name="Text 32"/>
+          <p:cNvSpPr/>
+          <p:nvPr/>
+        </p:nvSpPr>
+        <p:spPr>
+          <a:xfrm>
+            <a:off x="2286000" y="2935224"/>
             <a:ext cx="978408" cy="384048"/>
           </a:xfrm>
           <a:prstGeom prst="rect">
@@ -7507,7 +8027,7 @@
           <a:bodyPr wrap="square" rtlCol="0" anchor="ctr"/>
           <a:lstStyle/>
           <a:p>
-            <a:pPr algn="l" indent="0" marL="0">
+            <a:pPr marL="0" indent="0" algn="l">
               <a:buNone/>
             </a:pPr>
             <a:r>
@@ -7519,12 +8039,12 @@
                 <a:ea typeface="Calibri" pitchFamily="34" charset="-122"/>
                 <a:cs typeface="Calibri" pitchFamily="34" charset="-120"/>
               </a:rPr>
-              <a:t>Poll</a:t>
+              <a:t>Block</a:t>
             </a:r>
             <a:endParaRPr lang="en-US" sz="1100" dirty="0"/>
           </a:p>
           <a:p>
-            <a:pPr algn="l" indent="0" marL="0">
+            <a:pPr marL="0" indent="0" algn="l">
               <a:buNone/>
             </a:pPr>
             <a:r>
@@ -7536,7 +8056,7 @@
                 <a:ea typeface="Calibri" pitchFamily="34" charset="-122"/>
                 <a:cs typeface="Calibri" pitchFamily="34" charset="-120"/>
               </a:rPr>
-              <a:t>Queue</a:t>
+              <a:t>Key</a:t>
             </a:r>
             <a:endParaRPr lang="en-US" sz="1100" dirty="0"/>
           </a:p>
@@ -7544,13 +8064,13 @@
       </p:sp>
       <p:sp>
         <p:nvSpPr>
-          <p:cNvPr id="35" name="Text 28"/>
-          <p:cNvSpPr/>
-          <p:nvPr/>
-        </p:nvSpPr>
-        <p:spPr>
-          <a:xfrm>
-            <a:off x="411480" y="3374136"/>
+          <p:cNvPr id="41" name="Text 33"/>
+          <p:cNvSpPr/>
+          <p:nvPr/>
+        </p:nvSpPr>
+        <p:spPr>
+          <a:xfrm>
+            <a:off x="2057400" y="3374136"/>
             <a:ext cx="1252728" cy="502920"/>
           </a:xfrm>
           <a:prstGeom prst="rect">
@@ -7563,7 +8083,7 @@
           <a:bodyPr wrap="square" rtlCol="0" anchor="t"/>
           <a:lstStyle/>
           <a:p>
-            <a:pPr algn="l" indent="0" marL="0">
+            <a:pPr marL="0" indent="0" algn="l">
               <a:buNone/>
             </a:pPr>
             <a:r>
@@ -7575,12 +8095,12 @@
                 <a:ea typeface="Calibri" pitchFamily="34" charset="-122"/>
                 <a:cs typeface="Calibri" pitchFamily="34" charset="-120"/>
               </a:rPr>
-              <a:t>UNRESOLVED rows</a:t>
+              <a:t>routing:021…</a:t>
             </a:r>
             <a:endParaRPr lang="en-US" sz="1000" dirty="0"/>
           </a:p>
           <a:p>
-            <a:pPr algn="l" indent="0" marL="0">
+            <a:pPr marL="0" indent="0" algn="l">
               <a:buNone/>
             </a:pPr>
             <a:r>
@@ -7592,7 +8112,7 @@
                 <a:ea typeface="Calibri" pitchFamily="34" charset="-122"/>
                 <a:cs typeface="Calibri" pitchFamily="34" charset="-120"/>
               </a:rPr>
-              <a:t>IR queue view</a:t>
+              <a:t>proxy:hash…</a:t>
             </a:r>
             <a:endParaRPr lang="en-US" sz="1000" dirty="0"/>
           </a:p>
@@ -7600,13 +8120,13 @@
       </p:sp>
       <p:sp>
         <p:nvSpPr>
-          <p:cNvPr id="36" name="Text 29"/>
-          <p:cNvSpPr/>
-          <p:nvPr/>
-        </p:nvSpPr>
-        <p:spPr>
-          <a:xfrm>
-            <a:off x="1746504" y="3209544"/>
+          <p:cNvPr id="42" name="Text 34"/>
+          <p:cNvSpPr/>
+          <p:nvPr/>
+        </p:nvSpPr>
+        <p:spPr>
+          <a:xfrm>
+            <a:off x="3392424" y="3209544"/>
             <a:ext cx="201168" cy="274320"/>
           </a:xfrm>
           <a:prstGeom prst="rect">
@@ -7619,7 +8139,7 @@
           <a:bodyPr wrap="square" lIns="0" tIns="0" rIns="0" bIns="0" rtlCol="0" anchor="ctr"/>
           <a:lstStyle/>
           <a:p>
-            <a:pPr algn="ctr" indent="0" marL="0">
+            <a:pPr marL="0" indent="0" algn="ctr">
               <a:buNone/>
             </a:pPr>
             <a:r>
@@ -7636,13 +8156,13 @@
       </p:sp>
       <p:sp>
         <p:nvSpPr>
-          <p:cNvPr id="37" name="Shape 30"/>
-          <p:cNvSpPr/>
-          <p:nvPr/>
-        </p:nvSpPr>
-        <p:spPr>
-          <a:xfrm>
-            <a:off x="1965960" y="2862072"/>
+          <p:cNvPr id="43" name="Shape 35"/>
+          <p:cNvSpPr/>
+          <p:nvPr/>
+        </p:nvSpPr>
+        <p:spPr>
+          <a:xfrm>
+            <a:off x="3611880" y="2862072"/>
             <a:ext cx="1389888" cy="1078992"/>
           </a:xfrm>
           <a:prstGeom prst="rect">
@@ -7658,51 +8178,65 @@
             <a:prstDash val="solid"/>
           </a:ln>
           <a:effectLst>
-            <a:outerShdw sx="100000" sy="100000" kx="0" ky="0" algn="bl" rotWithShape="0" blurRad="101600" dist="25400" dir="8100000">
+            <a:outerShdw blurRad="101600" dist="25400" dir="8100000" algn="bl" rotWithShape="0">
               <a:srgbClr val="000000">
                 <a:alpha val="10000"/>
               </a:srgbClr>
             </a:outerShdw>
           </a:effectLst>
         </p:spPr>
-      </p:sp>
-      <p:sp>
-        <p:nvSpPr>
-          <p:cNvPr id="38" name="Shape 31"/>
-          <p:cNvSpPr/>
-          <p:nvPr/>
-        </p:nvSpPr>
-        <p:spPr>
-          <a:xfrm>
-            <a:off x="1965960" y="2862072"/>
+        <p:txBody>
+          <a:bodyPr/>
+          <a:lstStyle/>
+          <a:p>
+            <a:endParaRPr lang="en-US"/>
+          </a:p>
+        </p:txBody>
+      </p:sp>
+      <p:sp>
+        <p:nvSpPr>
+          <p:cNvPr id="44" name="Shape 36"/>
+          <p:cNvSpPr/>
+          <p:nvPr/>
+        </p:nvSpPr>
+        <p:spPr>
+          <a:xfrm>
+            <a:off x="3611880" y="2862072"/>
             <a:ext cx="1389888" cy="54864"/>
           </a:xfrm>
           <a:prstGeom prst="rect">
             <a:avLst/>
           </a:prstGeom>
           <a:solidFill>
-            <a:srgbClr val="065A82"/>
-          </a:solidFill>
-          <a:ln/>
-        </p:spPr>
+            <a:srgbClr val="1C7293"/>
+          </a:solidFill>
+          <a:ln/>
+        </p:spPr>
+        <p:txBody>
+          <a:bodyPr/>
+          <a:lstStyle/>
+          <a:p>
+            <a:endParaRPr lang="en-US"/>
+          </a:p>
+        </p:txBody>
       </p:sp>
       <p:pic>
         <p:nvPicPr>
-          <p:cNvPr id="39" name="Image 5" descr="preencoded.png">    </p:cNvPr>
+          <p:cNvPr id="45" name="Image 6" descr="preencoded.png"/>
           <p:cNvPicPr>
             <a:picLocks noChangeAspect="1"/>
           </p:cNvPicPr>
           <p:nvPr/>
         </p:nvPicPr>
         <p:blipFill>
-          <a:blip r:embed="rId6"/>
+          <a:blip r:embed="rId7"/>
           <a:stretch>
             <a:fillRect/>
           </a:stretch>
         </p:blipFill>
         <p:spPr>
           <a:xfrm>
-            <a:off x="2057400" y="2953512"/>
+            <a:off x="3703320" y="2953512"/>
             <a:ext cx="201168" cy="201168"/>
           </a:xfrm>
           <a:prstGeom prst="rect">
@@ -7712,13 +8246,13 @@
       </p:pic>
       <p:sp>
         <p:nvSpPr>
-          <p:cNvPr id="40" name="Text 32"/>
-          <p:cNvSpPr/>
-          <p:nvPr/>
-        </p:nvSpPr>
-        <p:spPr>
-          <a:xfrm>
-            <a:off x="2286000" y="2935224"/>
+          <p:cNvPr id="46" name="Text 37"/>
+          <p:cNvSpPr/>
+          <p:nvPr/>
+        </p:nvSpPr>
+        <p:spPr>
+          <a:xfrm>
+            <a:off x="3931920" y="2935224"/>
             <a:ext cx="978408" cy="384048"/>
           </a:xfrm>
           <a:prstGeom prst="rect">
@@ -7731,7 +8265,7 @@
           <a:bodyPr wrap="square" rtlCol="0" anchor="ctr"/>
           <a:lstStyle/>
           <a:p>
-            <a:pPr algn="l" indent="0" marL="0">
+            <a:pPr marL="0" indent="0" algn="l">
               <a:buNone/>
             </a:pPr>
             <a:r>
@@ -7743,12 +8277,12 @@
                 <a:ea typeface="Calibri" pitchFamily="34" charset="-122"/>
                 <a:cs typeface="Calibri" pitchFamily="34" charset="-120"/>
               </a:rPr>
-              <a:t>Block</a:t>
+              <a:t>Apply</a:t>
             </a:r>
             <a:endParaRPr lang="en-US" sz="1100" dirty="0"/>
           </a:p>
           <a:p>
-            <a:pPr algn="l" indent="0" marL="0">
+            <a:pPr marL="0" indent="0" algn="l">
               <a:buNone/>
             </a:pPr>
             <a:r>
@@ -7760,7 +8294,7 @@
                 <a:ea typeface="Calibri" pitchFamily="34" charset="-122"/>
                 <a:cs typeface="Calibri" pitchFamily="34" charset="-120"/>
               </a:rPr>
-              <a:t>Key</a:t>
+              <a:t>Rules</a:t>
             </a:r>
             <a:endParaRPr lang="en-US" sz="1100" dirty="0"/>
           </a:p>
@@ -7768,13 +8302,13 @@
       </p:sp>
       <p:sp>
         <p:nvSpPr>
-          <p:cNvPr id="41" name="Text 33"/>
-          <p:cNvSpPr/>
-          <p:nvPr/>
-        </p:nvSpPr>
-        <p:spPr>
-          <a:xfrm>
-            <a:off x="2057400" y="3374136"/>
+          <p:cNvPr id="47" name="Text 38"/>
+          <p:cNvSpPr/>
+          <p:nvPr/>
+        </p:nvSpPr>
+        <p:spPr>
+          <a:xfrm>
+            <a:off x="3703320" y="3374136"/>
             <a:ext cx="1252728" cy="502920"/>
           </a:xfrm>
           <a:prstGeom prst="rect">
@@ -7787,7 +8321,7 @@
           <a:bodyPr wrap="square" rtlCol="0" anchor="t"/>
           <a:lstStyle/>
           <a:p>
-            <a:pPr algn="l" indent="0" marL="0">
+            <a:pPr marL="0" indent="0" algn="l">
               <a:buNone/>
             </a:pPr>
             <a:r>
@@ -7799,12 +8333,12 @@
                 <a:ea typeface="Calibri" pitchFamily="34" charset="-122"/>
                 <a:cs typeface="Calibri" pitchFamily="34" charset="-120"/>
               </a:rPr>
-              <a:t>routing:021…</a:t>
+              <a:t>EXACT_TOKEN</a:t>
             </a:r>
             <a:endParaRPr lang="en-US" sz="1000" dirty="0"/>
           </a:p>
           <a:p>
-            <a:pPr algn="l" indent="0" marL="0">
+            <a:pPr marL="0" indent="0" algn="l">
               <a:buNone/>
             </a:pPr>
             <a:r>
@@ -7816,7 +8350,7 @@
                 <a:ea typeface="Calibri" pitchFamily="34" charset="-122"/>
                 <a:cs typeface="Calibri" pitchFamily="34" charset="-120"/>
               </a:rPr>
-              <a:t>proxy:hash…</a:t>
+              <a:t>ROUTING_ACCT</a:t>
             </a:r>
             <a:endParaRPr lang="en-US" sz="1000" dirty="0"/>
           </a:p>
@@ -7824,13 +8358,13 @@
       </p:sp>
       <p:sp>
         <p:nvSpPr>
-          <p:cNvPr id="42" name="Text 34"/>
-          <p:cNvSpPr/>
-          <p:nvPr/>
-        </p:nvSpPr>
-        <p:spPr>
-          <a:xfrm>
-            <a:off x="3392424" y="3209544"/>
+          <p:cNvPr id="48" name="Text 39"/>
+          <p:cNvSpPr/>
+          <p:nvPr/>
+        </p:nvSpPr>
+        <p:spPr>
+          <a:xfrm>
+            <a:off x="5038344" y="3209544"/>
             <a:ext cx="201168" cy="274320"/>
           </a:xfrm>
           <a:prstGeom prst="rect">
@@ -7843,7 +8377,7 @@
           <a:bodyPr wrap="square" lIns="0" tIns="0" rIns="0" bIns="0" rtlCol="0" anchor="ctr"/>
           <a:lstStyle/>
           <a:p>
-            <a:pPr algn="ctr" indent="0" marL="0">
+            <a:pPr marL="0" indent="0" algn="ctr">
               <a:buNone/>
             </a:pPr>
             <a:r>
@@ -7860,13 +8394,13 @@
       </p:sp>
       <p:sp>
         <p:nvSpPr>
-          <p:cNvPr id="43" name="Shape 35"/>
-          <p:cNvSpPr/>
-          <p:nvPr/>
-        </p:nvSpPr>
-        <p:spPr>
-          <a:xfrm>
-            <a:off x="3611880" y="2862072"/>
+          <p:cNvPr id="49" name="Shape 40"/>
+          <p:cNvSpPr/>
+          <p:nvPr/>
+        </p:nvSpPr>
+        <p:spPr>
+          <a:xfrm>
+            <a:off x="5257800" y="2862072"/>
             <a:ext cx="1389888" cy="1078992"/>
           </a:xfrm>
           <a:prstGeom prst="rect">
@@ -7882,261 +8416,51 @@
             <a:prstDash val="solid"/>
           </a:ln>
           <a:effectLst>
-            <a:outerShdw sx="100000" sy="100000" kx="0" ky="0" algn="bl" rotWithShape="0" blurRad="101600" dist="25400" dir="8100000">
+            <a:outerShdw blurRad="101600" dist="25400" dir="8100000" algn="bl" rotWithShape="0">
               <a:srgbClr val="000000">
                 <a:alpha val="10000"/>
               </a:srgbClr>
             </a:outerShdw>
           </a:effectLst>
         </p:spPr>
-      </p:sp>
-      <p:sp>
-        <p:nvSpPr>
-          <p:cNvPr id="44" name="Shape 36"/>
-          <p:cNvSpPr/>
-          <p:nvPr/>
-        </p:nvSpPr>
-        <p:spPr>
-          <a:xfrm>
-            <a:off x="3611880" y="2862072"/>
+        <p:txBody>
+          <a:bodyPr/>
+          <a:lstStyle/>
+          <a:p>
+            <a:endParaRPr lang="en-US"/>
+          </a:p>
+        </p:txBody>
+      </p:sp>
+      <p:sp>
+        <p:nvSpPr>
+          <p:cNvPr id="50" name="Shape 41"/>
+          <p:cNvSpPr/>
+          <p:nvPr/>
+        </p:nvSpPr>
+        <p:spPr>
+          <a:xfrm>
+            <a:off x="5257800" y="2862072"/>
             <a:ext cx="1389888" cy="54864"/>
           </a:xfrm>
           <a:prstGeom prst="rect">
             <a:avLst/>
           </a:prstGeom>
           <a:solidFill>
-            <a:srgbClr val="1C7293"/>
-          </a:solidFill>
-          <a:ln/>
-        </p:spPr>
+            <a:srgbClr val="02C39A"/>
+          </a:solidFill>
+          <a:ln/>
+        </p:spPr>
+        <p:txBody>
+          <a:bodyPr/>
+          <a:lstStyle/>
+          <a:p>
+            <a:endParaRPr lang="en-US"/>
+          </a:p>
+        </p:txBody>
       </p:sp>
       <p:pic>
         <p:nvPicPr>
-          <p:cNvPr id="45" name="Image 6" descr="preencoded.png">    </p:cNvPr>
-          <p:cNvPicPr>
-            <a:picLocks noChangeAspect="1"/>
-          </p:cNvPicPr>
-          <p:nvPr/>
-        </p:nvPicPr>
-        <p:blipFill>
-          <a:blip r:embed="rId7"/>
-          <a:stretch>
-            <a:fillRect/>
-          </a:stretch>
-        </p:blipFill>
-        <p:spPr>
-          <a:xfrm>
-            <a:off x="3703320" y="2953512"/>
-            <a:ext cx="201168" cy="201168"/>
-          </a:xfrm>
-          <a:prstGeom prst="rect">
-            <a:avLst/>
-          </a:prstGeom>
-        </p:spPr>
-      </p:pic>
-      <p:sp>
-        <p:nvSpPr>
-          <p:cNvPr id="46" name="Text 37"/>
-          <p:cNvSpPr/>
-          <p:nvPr/>
-        </p:nvSpPr>
-        <p:spPr>
-          <a:xfrm>
-            <a:off x="3931920" y="2935224"/>
-            <a:ext cx="978408" cy="384048"/>
-          </a:xfrm>
-          <a:prstGeom prst="rect">
-            <a:avLst/>
-          </a:prstGeom>
-          <a:noFill/>
-          <a:ln/>
-        </p:spPr>
-        <p:txBody>
-          <a:bodyPr wrap="square" rtlCol="0" anchor="ctr"/>
-          <a:lstStyle/>
-          <a:p>
-            <a:pPr algn="l" indent="0" marL="0">
-              <a:buNone/>
-            </a:pPr>
-            <a:r>
-              <a:rPr lang="en-US" sz="1100" b="1" dirty="0">
-                <a:solidFill>
-                  <a:srgbClr val="1A2B3C"/>
-                </a:solidFill>
-                <a:latin typeface="Calibri" pitchFamily="34" charset="0"/>
-                <a:ea typeface="Calibri" pitchFamily="34" charset="-122"/>
-                <a:cs typeface="Calibri" pitchFamily="34" charset="-120"/>
-              </a:rPr>
-              <a:t>Apply</a:t>
-            </a:r>
-            <a:endParaRPr lang="en-US" sz="1100" dirty="0"/>
-          </a:p>
-          <a:p>
-            <a:pPr algn="l" indent="0" marL="0">
-              <a:buNone/>
-            </a:pPr>
-            <a:r>
-              <a:rPr lang="en-US" sz="1100" b="1" dirty="0">
-                <a:solidFill>
-                  <a:srgbClr val="1A2B3C"/>
-                </a:solidFill>
-                <a:latin typeface="Calibri" pitchFamily="34" charset="0"/>
-                <a:ea typeface="Calibri" pitchFamily="34" charset="-122"/>
-                <a:cs typeface="Calibri" pitchFamily="34" charset="-120"/>
-              </a:rPr>
-              <a:t>Rules</a:t>
-            </a:r>
-            <a:endParaRPr lang="en-US" sz="1100" dirty="0"/>
-          </a:p>
-        </p:txBody>
-      </p:sp>
-      <p:sp>
-        <p:nvSpPr>
-          <p:cNvPr id="47" name="Text 38"/>
-          <p:cNvSpPr/>
-          <p:nvPr/>
-        </p:nvSpPr>
-        <p:spPr>
-          <a:xfrm>
-            <a:off x="3703320" y="3374136"/>
-            <a:ext cx="1252728" cy="502920"/>
-          </a:xfrm>
-          <a:prstGeom prst="rect">
-            <a:avLst/>
-          </a:prstGeom>
-          <a:noFill/>
-          <a:ln/>
-        </p:spPr>
-        <p:txBody>
-          <a:bodyPr wrap="square" rtlCol="0" anchor="t"/>
-          <a:lstStyle/>
-          <a:p>
-            <a:pPr algn="l" indent="0" marL="0">
-              <a:buNone/>
-            </a:pPr>
-            <a:r>
-              <a:rPr lang="en-US" sz="1000" dirty="0">
-                <a:solidFill>
-                  <a:srgbClr val="4A6080"/>
-                </a:solidFill>
-                <a:latin typeface="Calibri" pitchFamily="34" charset="0"/>
-                <a:ea typeface="Calibri" pitchFamily="34" charset="-122"/>
-                <a:cs typeface="Calibri" pitchFamily="34" charset="-120"/>
-              </a:rPr>
-              <a:t>EXACT_TOKEN</a:t>
-            </a:r>
-            <a:endParaRPr lang="en-US" sz="1000" dirty="0"/>
-          </a:p>
-          <a:p>
-            <a:pPr algn="l" indent="0" marL="0">
-              <a:buNone/>
-            </a:pPr>
-            <a:r>
-              <a:rPr lang="en-US" sz="1000" dirty="0">
-                <a:solidFill>
-                  <a:srgbClr val="4A6080"/>
-                </a:solidFill>
-                <a:latin typeface="Calibri" pitchFamily="34" charset="0"/>
-                <a:ea typeface="Calibri" pitchFamily="34" charset="-122"/>
-                <a:cs typeface="Calibri" pitchFamily="34" charset="-120"/>
-              </a:rPr>
-              <a:t>ROUTING_ACCT</a:t>
-            </a:r>
-            <a:endParaRPr lang="en-US" sz="1000" dirty="0"/>
-          </a:p>
-        </p:txBody>
-      </p:sp>
-      <p:sp>
-        <p:nvSpPr>
-          <p:cNvPr id="48" name="Text 39"/>
-          <p:cNvSpPr/>
-          <p:nvPr/>
-        </p:nvSpPr>
-        <p:spPr>
-          <a:xfrm>
-            <a:off x="5038344" y="3209544"/>
-            <a:ext cx="201168" cy="274320"/>
-          </a:xfrm>
-          <a:prstGeom prst="rect">
-            <a:avLst/>
-          </a:prstGeom>
-          <a:noFill/>
-          <a:ln/>
-        </p:spPr>
-        <p:txBody>
-          <a:bodyPr wrap="square" lIns="0" tIns="0" rIns="0" bIns="0" rtlCol="0" anchor="ctr"/>
-          <a:lstStyle/>
-          <a:p>
-            <a:pPr algn="ctr" indent="0" marL="0">
-              <a:buNone/>
-            </a:pPr>
-            <a:r>
-              <a:rPr lang="en-US" sz="1100" dirty="0">
-                <a:solidFill>
-                  <a:srgbClr val="02C39A"/>
-                </a:solidFill>
-              </a:rPr>
-              <a:t>▶</a:t>
-            </a:r>
-            <a:endParaRPr lang="en-US" sz="1100" dirty="0"/>
-          </a:p>
-        </p:txBody>
-      </p:sp>
-      <p:sp>
-        <p:nvSpPr>
-          <p:cNvPr id="49" name="Shape 40"/>
-          <p:cNvSpPr/>
-          <p:nvPr/>
-        </p:nvSpPr>
-        <p:spPr>
-          <a:xfrm>
-            <a:off x="5257800" y="2862072"/>
-            <a:ext cx="1389888" cy="1078992"/>
-          </a:xfrm>
-          <a:prstGeom prst="rect">
-            <a:avLst/>
-          </a:prstGeom>
-          <a:solidFill>
-            <a:srgbClr val="FFFFFF"/>
-          </a:solidFill>
-          <a:ln w="12700">
-            <a:solidFill>
-              <a:srgbClr val="D0DDE8"/>
-            </a:solidFill>
-            <a:prstDash val="solid"/>
-          </a:ln>
-          <a:effectLst>
-            <a:outerShdw sx="100000" sy="100000" kx="0" ky="0" algn="bl" rotWithShape="0" blurRad="101600" dist="25400" dir="8100000">
-              <a:srgbClr val="000000">
-                <a:alpha val="10000"/>
-              </a:srgbClr>
-            </a:outerShdw>
-          </a:effectLst>
-        </p:spPr>
-      </p:sp>
-      <p:sp>
-        <p:nvSpPr>
-          <p:cNvPr id="50" name="Shape 41"/>
-          <p:cNvSpPr/>
-          <p:nvPr/>
-        </p:nvSpPr>
-        <p:spPr>
-          <a:xfrm>
-            <a:off x="5257800" y="2862072"/>
-            <a:ext cx="1389888" cy="54864"/>
-          </a:xfrm>
-          <a:prstGeom prst="rect">
-            <a:avLst/>
-          </a:prstGeom>
-          <a:solidFill>
-            <a:srgbClr val="02C39A"/>
-          </a:solidFill>
-          <a:ln/>
-        </p:spPr>
-      </p:sp>
-      <p:pic>
-        <p:nvPicPr>
-          <p:cNvPr id="51" name="Image 7" descr="preencoded.png">    </p:cNvPr>
+          <p:cNvPr id="51" name="Image 7" descr="preencoded.png"/>
           <p:cNvPicPr>
             <a:picLocks noChangeAspect="1"/>
           </p:cNvPicPr>
@@ -8179,7 +8503,7 @@
           <a:bodyPr wrap="square" rtlCol="0" anchor="ctr"/>
           <a:lstStyle/>
           <a:p>
-            <a:pPr algn="l" indent="0" marL="0">
+            <a:pPr marL="0" indent="0" algn="l">
               <a:buNone/>
             </a:pPr>
             <a:r>
@@ -8196,7 +8520,7 @@
             <a:endParaRPr lang="en-US" sz="1100" dirty="0"/>
           </a:p>
           <a:p>
-            <a:pPr algn="l" indent="0" marL="0">
+            <a:pPr marL="0" indent="0" algn="l">
               <a:buNone/>
             </a:pPr>
             <a:r>
@@ -8235,7 +8559,7 @@
           <a:bodyPr wrap="square" rtlCol="0" anchor="t"/>
           <a:lstStyle/>
           <a:p>
-            <a:pPr algn="l" indent="0" marL="0">
+            <a:pPr marL="0" indent="0" algn="l">
               <a:buNone/>
             </a:pPr>
             <a:r>
@@ -8252,7 +8576,7 @@
             <a:endParaRPr lang="en-US" sz="1000" dirty="0"/>
           </a:p>
           <a:p>
-            <a:pPr algn="l" indent="0" marL="0">
+            <a:pPr marL="0" indent="0" algn="l">
               <a:buNone/>
             </a:pPr>
             <a:r>
@@ -8294,13 +8618,20 @@
             <a:prstDash val="solid"/>
           </a:ln>
           <a:effectLst>
-            <a:outerShdw sx="100000" sy="100000" kx="0" ky="0" algn="bl" rotWithShape="0" blurRad="177800" dist="50800" dir="8100000">
+            <a:outerShdw blurRad="177800" dist="50800" dir="8100000" algn="bl" rotWithShape="0">
               <a:srgbClr val="000000">
                 <a:alpha val="15000"/>
               </a:srgbClr>
             </a:outerShdw>
           </a:effectLst>
         </p:spPr>
+        <p:txBody>
+          <a:bodyPr/>
+          <a:lstStyle/>
+          <a:p>
+            <a:endParaRPr lang="en-US"/>
+          </a:p>
+        </p:txBody>
       </p:sp>
       <p:sp>
         <p:nvSpPr>
@@ -8321,10 +8652,17 @@
           </a:solidFill>
           <a:ln/>
         </p:spPr>
+        <p:txBody>
+          <a:bodyPr/>
+          <a:lstStyle/>
+          <a:p>
+            <a:endParaRPr lang="en-US"/>
+          </a:p>
+        </p:txBody>
       </p:sp>
       <p:pic>
         <p:nvPicPr>
-          <p:cNvPr id="56" name="Image 8" descr="preencoded.png">    </p:cNvPr>
+          <p:cNvPr id="56" name="Image 8" descr="preencoded.png"/>
           <p:cNvPicPr>
             <a:picLocks noChangeAspect="1"/>
           </p:cNvPicPr>
@@ -8367,7 +8705,7 @@
           <a:bodyPr wrap="square" lIns="0" tIns="0" rIns="0" bIns="0" rtlCol="0" anchor="ctr"/>
           <a:lstStyle/>
           <a:p>
-            <a:pPr algn="l" indent="0" marL="0">
+            <a:pPr marL="0" indent="0" algn="l">
               <a:buNone/>
             </a:pPr>
             <a:r>
@@ -8518,7 +8856,7 @@
           <a:bodyPr wrap="square" lIns="0" tIns="0" rIns="0" bIns="0" rtlCol="0" anchor="ctr"/>
           <a:lstStyle/>
           <a:p>
-            <a:pPr algn="r" indent="0" marL="0">
+            <a:pPr marL="0" indent="0" algn="r">
               <a:buNone/>
             </a:pPr>
             <a:r>
@@ -8552,6 +8890,7 @@
         <a:solidFill>
           <a:srgbClr val="0A2342"/>
         </a:solidFill>
+        <a:effectLst/>
       </p:bgPr>
     </p:bg>
     <p:spTree>
@@ -8587,6 +8926,13 @@
           </a:solidFill>
           <a:ln/>
         </p:spPr>
+        <p:txBody>
+          <a:bodyPr/>
+          <a:lstStyle/>
+          <a:p>
+            <a:endParaRPr lang="en-US"/>
+          </a:p>
+        </p:txBody>
       </p:sp>
       <p:sp>
         <p:nvSpPr>
@@ -8609,6 +8955,13 @@
           </a:solidFill>
           <a:ln/>
         </p:spPr>
+        <p:txBody>
+          <a:bodyPr/>
+          <a:lstStyle/>
+          <a:p>
+            <a:endParaRPr lang="en-US"/>
+          </a:p>
+        </p:txBody>
       </p:sp>
       <p:sp>
         <p:nvSpPr>
@@ -8631,7 +8984,7 @@
           <a:bodyPr wrap="square" lIns="0" tIns="0" rIns="0" bIns="0" rtlCol="0" anchor="ctr"/>
           <a:lstStyle/>
           <a:p>
-            <a:pPr algn="l" indent="0" marL="0">
+            <a:pPr marL="0" indent="0" algn="l">
               <a:buNone/>
             </a:pPr>
             <a:r>
@@ -8673,13 +9026,20 @@
             <a:prstDash val="solid"/>
           </a:ln>
           <a:effectLst>
-            <a:outerShdw sx="100000" sy="100000" kx="0" ky="0" algn="bl" rotWithShape="0" blurRad="101600" dist="25400" dir="8100000">
+            <a:outerShdw blurRad="101600" dist="25400" dir="8100000" algn="bl" rotWithShape="0">
               <a:srgbClr val="000000">
                 <a:alpha val="10000"/>
               </a:srgbClr>
             </a:outerShdw>
           </a:effectLst>
         </p:spPr>
+        <p:txBody>
+          <a:bodyPr/>
+          <a:lstStyle/>
+          <a:p>
+            <a:endParaRPr lang="en-US"/>
+          </a:p>
+        </p:txBody>
       </p:sp>
       <p:sp>
         <p:nvSpPr>
@@ -8702,7 +9062,7 @@
           <a:bodyPr wrap="square" lIns="0" tIns="0" rIns="0" bIns="0" rtlCol="0" anchor="ctr"/>
           <a:lstStyle/>
           <a:p>
-            <a:pPr algn="ctr" indent="0" marL="0">
+            <a:pPr marL="0" indent="0" algn="ctr">
               <a:buNone/>
             </a:pPr>
             <a:r>
@@ -8741,7 +9101,7 @@
           <a:bodyPr wrap="square" lIns="0" tIns="0" rIns="0" bIns="0" rtlCol="0" anchor="ctr"/>
           <a:lstStyle/>
           <a:p>
-            <a:pPr algn="ctr" indent="0" marL="0">
+            <a:pPr marL="0" indent="0" algn="ctr">
               <a:buNone/>
             </a:pPr>
             <a:r>
@@ -8783,13 +9143,20 @@
             <a:prstDash val="solid"/>
           </a:ln>
           <a:effectLst>
-            <a:outerShdw sx="100000" sy="100000" kx="0" ky="0" algn="bl" rotWithShape="0" blurRad="101600" dist="25400" dir="8100000">
+            <a:outerShdw blurRad="101600" dist="25400" dir="8100000" algn="bl" rotWithShape="0">
               <a:srgbClr val="000000">
                 <a:alpha val="10000"/>
               </a:srgbClr>
             </a:outerShdw>
           </a:effectLst>
         </p:spPr>
+        <p:txBody>
+          <a:bodyPr/>
+          <a:lstStyle/>
+          <a:p>
+            <a:endParaRPr lang="en-US"/>
+          </a:p>
+        </p:txBody>
       </p:sp>
       <p:sp>
         <p:nvSpPr>
@@ -8812,7 +9179,7 @@
           <a:bodyPr wrap="square" lIns="0" tIns="0" rIns="0" bIns="0" rtlCol="0" anchor="ctr"/>
           <a:lstStyle/>
           <a:p>
-            <a:pPr algn="ctr" indent="0" marL="0">
+            <a:pPr marL="0" indent="0" algn="ctr">
               <a:buNone/>
             </a:pPr>
             <a:r>
@@ -8851,7 +9218,7 @@
           <a:bodyPr wrap="square" lIns="0" tIns="0" rIns="0" bIns="0" rtlCol="0" anchor="ctr"/>
           <a:lstStyle/>
           <a:p>
-            <a:pPr algn="ctr" indent="0" marL="0">
+            <a:pPr marL="0" indent="0" algn="ctr">
               <a:buNone/>
             </a:pPr>
             <a:r>
@@ -8893,13 +9260,20 @@
             <a:prstDash val="solid"/>
           </a:ln>
           <a:effectLst>
-            <a:outerShdw sx="100000" sy="100000" kx="0" ky="0" algn="bl" rotWithShape="0" blurRad="101600" dist="25400" dir="8100000">
+            <a:outerShdw blurRad="101600" dist="25400" dir="8100000" algn="bl" rotWithShape="0">
               <a:srgbClr val="000000">
                 <a:alpha val="10000"/>
               </a:srgbClr>
             </a:outerShdw>
           </a:effectLst>
         </p:spPr>
+        <p:txBody>
+          <a:bodyPr/>
+          <a:lstStyle/>
+          <a:p>
+            <a:endParaRPr lang="en-US"/>
+          </a:p>
+        </p:txBody>
       </p:sp>
       <p:sp>
         <p:nvSpPr>
@@ -8922,7 +9296,7 @@
           <a:bodyPr wrap="square" lIns="0" tIns="0" rIns="0" bIns="0" rtlCol="0" anchor="ctr"/>
           <a:lstStyle/>
           <a:p>
-            <a:pPr algn="ctr" indent="0" marL="0">
+            <a:pPr marL="0" indent="0" algn="ctr">
               <a:buNone/>
             </a:pPr>
             <a:r>
@@ -8961,7 +9335,7 @@
           <a:bodyPr wrap="square" lIns="0" tIns="0" rIns="0" bIns="0" rtlCol="0" anchor="ctr"/>
           <a:lstStyle/>
           <a:p>
-            <a:pPr algn="ctr" indent="0" marL="0">
+            <a:pPr marL="0" indent="0" algn="ctr">
               <a:buNone/>
             </a:pPr>
             <a:r>
@@ -9003,13 +9377,20 @@
             <a:prstDash val="solid"/>
           </a:ln>
           <a:effectLst>
-            <a:outerShdw sx="100000" sy="100000" kx="0" ky="0" algn="bl" rotWithShape="0" blurRad="101600" dist="25400" dir="8100000">
+            <a:outerShdw blurRad="101600" dist="25400" dir="8100000" algn="bl" rotWithShape="0">
               <a:srgbClr val="000000">
                 <a:alpha val="10000"/>
               </a:srgbClr>
             </a:outerShdw>
           </a:effectLst>
         </p:spPr>
+        <p:txBody>
+          <a:bodyPr/>
+          <a:lstStyle/>
+          <a:p>
+            <a:endParaRPr lang="en-US"/>
+          </a:p>
+        </p:txBody>
       </p:sp>
       <p:sp>
         <p:nvSpPr>
@@ -9032,7 +9413,7 @@
           <a:bodyPr wrap="square" lIns="0" tIns="0" rIns="0" bIns="0" rtlCol="0" anchor="ctr"/>
           <a:lstStyle/>
           <a:p>
-            <a:pPr algn="ctr" indent="0" marL="0">
+            <a:pPr marL="0" indent="0" algn="ctr">
               <a:buNone/>
             </a:pPr>
             <a:r>
@@ -9071,7 +9452,7 @@
           <a:bodyPr wrap="square" lIns="0" tIns="0" rIns="0" bIns="0" rtlCol="0" anchor="ctr"/>
           <a:lstStyle/>
           <a:p>
-            <a:pPr algn="ctr" indent="0" marL="0">
+            <a:pPr marL="0" indent="0" algn="ctr">
               <a:buNone/>
             </a:pPr>
             <a:r>
@@ -9113,13 +9494,20 @@
             <a:prstDash val="solid"/>
           </a:ln>
           <a:effectLst>
-            <a:outerShdw sx="100000" sy="100000" kx="0" ky="0" algn="bl" rotWithShape="0" blurRad="101600" dist="25400" dir="8100000">
+            <a:outerShdw blurRad="101600" dist="25400" dir="8100000" algn="bl" rotWithShape="0">
               <a:srgbClr val="000000">
                 <a:alpha val="10000"/>
               </a:srgbClr>
             </a:outerShdw>
           </a:effectLst>
         </p:spPr>
+        <p:txBody>
+          <a:bodyPr/>
+          <a:lstStyle/>
+          <a:p>
+            <a:endParaRPr lang="en-US"/>
+          </a:p>
+        </p:txBody>
       </p:sp>
       <p:sp>
         <p:nvSpPr>
@@ -9142,7 +9530,7 @@
           <a:bodyPr wrap="square" lIns="0" tIns="0" rIns="0" bIns="0" rtlCol="0" anchor="ctr"/>
           <a:lstStyle/>
           <a:p>
-            <a:pPr algn="ctr" indent="0" marL="0">
+            <a:pPr marL="0" indent="0" algn="ctr">
               <a:buNone/>
             </a:pPr>
             <a:r>
@@ -9181,7 +9569,7 @@
           <a:bodyPr wrap="square" lIns="0" tIns="0" rIns="0" bIns="0" rtlCol="0" anchor="ctr"/>
           <a:lstStyle/>
           <a:p>
-            <a:pPr algn="ctr" indent="0" marL="0">
+            <a:pPr marL="0" indent="0" algn="ctr">
               <a:buNone/>
             </a:pPr>
             <a:r>
@@ -9389,7 +9777,7 @@
           <a:bodyPr wrap="square" lIns="0" tIns="0" rIns="0" bIns="0" rtlCol="0" anchor="ctr"/>
           <a:lstStyle/>
           <a:p>
-            <a:pPr algn="l" indent="0" marL="0">
+            <a:pPr marL="0" indent="0" algn="l">
               <a:buNone/>
             </a:pPr>
             <a:r>
@@ -9409,14 +9797,14 @@
       </p:sp>
       <p:pic>
         <p:nvPicPr>
-          <p:cNvPr id="22" name="Image 0" descr="preencoded.png">    </p:cNvPr>
+          <p:cNvPr id="22" name="Image 0" descr="preencoded.png"/>
           <p:cNvPicPr>
             <a:picLocks noChangeAspect="1"/>
           </p:cNvPicPr>
           <p:nvPr/>
         </p:nvPicPr>
         <p:blipFill>
-          <a:blip r:embed="rId1"/>
+          <a:blip r:embed="rId3"/>
           <a:stretch>
             <a:fillRect/>
           </a:stretch>
@@ -9732,4 +10120,319 @@
     </a:ext>
   </a:extLst>
 </a:theme>
+</file>
+
+<file path=ppt/theme/theme2.xml><?xml version="1.0" encoding="utf-8"?>
+<a:theme xmlns:a="http://schemas.openxmlformats.org/drawingml/2006/main" name="Office Theme">
+  <a:themeElements>
+    <a:clrScheme name="Office">
+      <a:dk1>
+        <a:sysClr val="windowText" lastClr="000000"/>
+      </a:dk1>
+      <a:lt1>
+        <a:sysClr val="window" lastClr="FFFFFF"/>
+      </a:lt1>
+      <a:dk2>
+        <a:srgbClr val="0E2841"/>
+      </a:dk2>
+      <a:lt2>
+        <a:srgbClr val="E8E8E8"/>
+      </a:lt2>
+      <a:accent1>
+        <a:srgbClr val="156082"/>
+      </a:accent1>
+      <a:accent2>
+        <a:srgbClr val="E97132"/>
+      </a:accent2>
+      <a:accent3>
+        <a:srgbClr val="196B24"/>
+      </a:accent3>
+      <a:accent4>
+        <a:srgbClr val="0F9ED5"/>
+      </a:accent4>
+      <a:accent5>
+        <a:srgbClr val="A02B93"/>
+      </a:accent5>
+      <a:accent6>
+        <a:srgbClr val="4EA72E"/>
+      </a:accent6>
+      <a:hlink>
+        <a:srgbClr val="467886"/>
+      </a:hlink>
+      <a:folHlink>
+        <a:srgbClr val="96607D"/>
+      </a:folHlink>
+    </a:clrScheme>
+    <a:fontScheme name="Office">
+      <a:majorFont>
+        <a:latin typeface="Aptos Display" panose="02110004020202020204"/>
+        <a:ea typeface=""/>
+        <a:cs typeface=""/>
+        <a:font script="Jpan" typeface="游ゴシック Light"/>
+        <a:font script="Hang" typeface="맑은 고딕"/>
+        <a:font script="Hans" typeface="等线 Light"/>
+        <a:font script="Hant" typeface="新細明體"/>
+        <a:font script="Arab" typeface="Times New Roman"/>
+        <a:font script="Hebr" typeface="Times New Roman"/>
+        <a:font script="Thai" typeface="Angsana New"/>
+        <a:font script="Ethi" typeface="Nyala"/>
+        <a:font script="Beng" typeface="Vrinda"/>
+        <a:font script="Gujr" typeface="Shruti"/>
+        <a:font script="Khmr" typeface="MoolBoran"/>
+        <a:font script="Knda" typeface="Tunga"/>
+        <a:font script="Guru" typeface="Raavi"/>
+        <a:font script="Cans" typeface="Euphemia"/>
+        <a:font script="Cher" typeface="Plantagenet Cherokee"/>
+        <a:font script="Yiii" typeface="Microsoft Yi Baiti"/>
+        <a:font script="Tibt" typeface="Microsoft Himalaya"/>
+        <a:font script="Thaa" typeface="MV Boli"/>
+        <a:font script="Deva" typeface="Mangal"/>
+        <a:font script="Telu" typeface="Gautami"/>
+        <a:font script="Taml" typeface="Latha"/>
+        <a:font script="Syrc" typeface="Estrangelo Edessa"/>
+        <a:font script="Orya" typeface="Kalinga"/>
+        <a:font script="Mlym" typeface="Kartika"/>
+        <a:font script="Laoo" typeface="DokChampa"/>
+        <a:font script="Sinh" typeface="Iskoola Pota"/>
+        <a:font script="Mong" typeface="Mongolian Baiti"/>
+        <a:font script="Viet" typeface="Times New Roman"/>
+        <a:font script="Uigh" typeface="Microsoft Uighur"/>
+        <a:font script="Geor" typeface="Sylfaen"/>
+        <a:font script="Armn" typeface="Arial"/>
+        <a:font script="Bugi" typeface="Leelawadee UI"/>
+        <a:font script="Bopo" typeface="Microsoft JhengHei"/>
+        <a:font script="Java" typeface="Javanese Text"/>
+        <a:font script="Lisu" typeface="Segoe UI"/>
+        <a:font script="Mymr" typeface="Myanmar Text"/>
+        <a:font script="Nkoo" typeface="Ebrima"/>
+        <a:font script="Olck" typeface="Nirmala UI"/>
+        <a:font script="Osma" typeface="Ebrima"/>
+        <a:font script="Phag" typeface="Phagspa"/>
+        <a:font script="Syrn" typeface="Estrangelo Edessa"/>
+        <a:font script="Syrj" typeface="Estrangelo Edessa"/>
+        <a:font script="Syre" typeface="Estrangelo Edessa"/>
+        <a:font script="Sora" typeface="Nirmala UI"/>
+        <a:font script="Tale" typeface="Microsoft Tai Le"/>
+        <a:font script="Talu" typeface="Microsoft New Tai Lue"/>
+        <a:font script="Tfng" typeface="Ebrima"/>
+      </a:majorFont>
+      <a:minorFont>
+        <a:latin typeface="Aptos" panose="02110004020202020204"/>
+        <a:ea typeface=""/>
+        <a:cs typeface=""/>
+        <a:font script="Jpan" typeface="游ゴシック"/>
+        <a:font script="Hang" typeface="맑은 고딕"/>
+        <a:font script="Hans" typeface="等线"/>
+        <a:font script="Hant" typeface="新細明體"/>
+        <a:font script="Arab" typeface="Arial"/>
+        <a:font script="Hebr" typeface="Arial"/>
+        <a:font script="Thai" typeface="Cordia New"/>
+        <a:font script="Ethi" typeface="Nyala"/>
+        <a:font script="Beng" typeface="Vrinda"/>
+        <a:font script="Gujr" typeface="Shruti"/>
+        <a:font script="Khmr" typeface="DaunPenh"/>
+        <a:font script="Knda" typeface="Tunga"/>
+        <a:font script="Guru" typeface="Raavi"/>
+        <a:font script="Cans" typeface="Euphemia"/>
+        <a:font script="Cher" typeface="Plantagenet Cherokee"/>
+        <a:font script="Yiii" typeface="Microsoft Yi Baiti"/>
+        <a:font script="Tibt" typeface="Microsoft Himalaya"/>
+        <a:font script="Thaa" typeface="MV Boli"/>
+        <a:font script="Deva" typeface="Mangal"/>
+        <a:font script="Telu" typeface="Gautami"/>
+        <a:font script="Taml" typeface="Latha"/>
+        <a:font script="Syrc" typeface="Estrangelo Edessa"/>
+        <a:font script="Orya" typeface="Kalinga"/>
+        <a:font script="Mlym" typeface="Kartika"/>
+        <a:font script="Laoo" typeface="DokChampa"/>
+        <a:font script="Sinh" typeface="Iskoola Pota"/>
+        <a:font script="Mong" typeface="Mongolian Baiti"/>
+        <a:font script="Viet" typeface="Arial"/>
+        <a:font script="Uigh" typeface="Microsoft Uighur"/>
+        <a:font script="Geor" typeface="Sylfaen"/>
+        <a:font script="Armn" typeface="Arial"/>
+        <a:font script="Bugi" typeface="Leelawadee UI"/>
+        <a:font script="Bopo" typeface="Microsoft JhengHei"/>
+        <a:font script="Java" typeface="Javanese Text"/>
+        <a:font script="Lisu" typeface="Segoe UI"/>
+        <a:font script="Mymr" typeface="Myanmar Text"/>
+        <a:font script="Nkoo" typeface="Ebrima"/>
+        <a:font script="Olck" typeface="Nirmala UI"/>
+        <a:font script="Osma" typeface="Ebrima"/>
+        <a:font script="Phag" typeface="Phagspa"/>
+        <a:font script="Syrn" typeface="Estrangelo Edessa"/>
+        <a:font script="Syrj" typeface="Estrangelo Edessa"/>
+        <a:font script="Syre" typeface="Estrangelo Edessa"/>
+        <a:font script="Sora" typeface="Nirmala UI"/>
+        <a:font script="Tale" typeface="Microsoft Tai Le"/>
+        <a:font script="Talu" typeface="Microsoft New Tai Lue"/>
+        <a:font script="Tfng" typeface="Ebrima"/>
+      </a:minorFont>
+    </a:fontScheme>
+    <a:fmtScheme name="Office">
+      <a:fillStyleLst>
+        <a:solidFill>
+          <a:schemeClr val="phClr"/>
+        </a:solidFill>
+        <a:gradFill rotWithShape="1">
+          <a:gsLst>
+            <a:gs pos="0">
+              <a:schemeClr val="phClr">
+                <a:lumMod val="110000"/>
+                <a:satMod val="105000"/>
+                <a:tint val="67000"/>
+              </a:schemeClr>
+            </a:gs>
+            <a:gs pos="50000">
+              <a:schemeClr val="phClr">
+                <a:lumMod val="105000"/>
+                <a:satMod val="103000"/>
+                <a:tint val="73000"/>
+              </a:schemeClr>
+            </a:gs>
+            <a:gs pos="100000">
+              <a:schemeClr val="phClr">
+                <a:lumMod val="105000"/>
+                <a:satMod val="109000"/>
+                <a:tint val="81000"/>
+              </a:schemeClr>
+            </a:gs>
+          </a:gsLst>
+          <a:lin ang="5400000" scaled="0"/>
+        </a:gradFill>
+        <a:gradFill rotWithShape="1">
+          <a:gsLst>
+            <a:gs pos="0">
+              <a:schemeClr val="phClr">
+                <a:satMod val="103000"/>
+                <a:lumMod val="102000"/>
+                <a:tint val="94000"/>
+              </a:schemeClr>
+            </a:gs>
+            <a:gs pos="50000">
+              <a:schemeClr val="phClr">
+                <a:satMod val="110000"/>
+                <a:lumMod val="100000"/>
+                <a:shade val="100000"/>
+              </a:schemeClr>
+            </a:gs>
+            <a:gs pos="100000">
+              <a:schemeClr val="phClr">
+                <a:lumMod val="99000"/>
+                <a:satMod val="120000"/>
+                <a:shade val="78000"/>
+              </a:schemeClr>
+            </a:gs>
+          </a:gsLst>
+          <a:lin ang="5400000" scaled="0"/>
+        </a:gradFill>
+      </a:fillStyleLst>
+      <a:lnStyleLst>
+        <a:ln w="12700" cap="flat" cmpd="sng" algn="ctr">
+          <a:solidFill>
+            <a:schemeClr val="phClr"/>
+          </a:solidFill>
+          <a:prstDash val="solid"/>
+          <a:miter lim="800000"/>
+        </a:ln>
+        <a:ln w="19050" cap="flat" cmpd="sng" algn="ctr">
+          <a:solidFill>
+            <a:schemeClr val="phClr"/>
+          </a:solidFill>
+          <a:prstDash val="solid"/>
+          <a:miter lim="800000"/>
+        </a:ln>
+        <a:ln w="25400" cap="flat" cmpd="sng" algn="ctr">
+          <a:solidFill>
+            <a:schemeClr val="phClr"/>
+          </a:solidFill>
+          <a:prstDash val="solid"/>
+          <a:miter lim="800000"/>
+        </a:ln>
+      </a:lnStyleLst>
+      <a:effectStyleLst>
+        <a:effectStyle>
+          <a:effectLst/>
+        </a:effectStyle>
+        <a:effectStyle>
+          <a:effectLst/>
+        </a:effectStyle>
+        <a:effectStyle>
+          <a:effectLst>
+            <a:outerShdw blurRad="57150" dist="19050" dir="5400000" algn="ctr" rotWithShape="0">
+              <a:srgbClr val="000000">
+                <a:alpha val="63000"/>
+              </a:srgbClr>
+            </a:outerShdw>
+          </a:effectLst>
+        </a:effectStyle>
+      </a:effectStyleLst>
+      <a:bgFillStyleLst>
+        <a:solidFill>
+          <a:schemeClr val="phClr"/>
+        </a:solidFill>
+        <a:solidFill>
+          <a:schemeClr val="phClr">
+            <a:tint val="95000"/>
+            <a:satMod val="170000"/>
+          </a:schemeClr>
+        </a:solidFill>
+        <a:gradFill rotWithShape="1">
+          <a:gsLst>
+            <a:gs pos="0">
+              <a:schemeClr val="phClr">
+                <a:tint val="93000"/>
+                <a:satMod val="150000"/>
+                <a:shade val="98000"/>
+                <a:lumMod val="102000"/>
+              </a:schemeClr>
+            </a:gs>
+            <a:gs pos="50000">
+              <a:schemeClr val="phClr">
+                <a:tint val="98000"/>
+                <a:satMod val="130000"/>
+                <a:shade val="90000"/>
+                <a:lumMod val="103000"/>
+              </a:schemeClr>
+            </a:gs>
+            <a:gs pos="100000">
+              <a:schemeClr val="phClr">
+                <a:shade val="63000"/>
+                <a:satMod val="120000"/>
+              </a:schemeClr>
+            </a:gs>
+          </a:gsLst>
+          <a:lin ang="5400000" scaled="0"/>
+        </a:gradFill>
+      </a:bgFillStyleLst>
+    </a:fmtScheme>
+  </a:themeElements>
+  <a:objectDefaults>
+    <a:lnDef>
+      <a:spPr/>
+      <a:bodyPr/>
+      <a:lstStyle/>
+      <a:style>
+        <a:lnRef idx="2">
+          <a:schemeClr val="accent1"/>
+        </a:lnRef>
+        <a:fillRef idx="0">
+          <a:schemeClr val="accent1"/>
+        </a:fillRef>
+        <a:effectRef idx="1">
+          <a:schemeClr val="accent1"/>
+        </a:effectRef>
+        <a:fontRef idx="minor">
+          <a:schemeClr val="tx1"/>
+        </a:fontRef>
+      </a:style>
+    </a:lnDef>
+  </a:objectDefaults>
+  <a:extraClrSchemeLst/>
+  <a:extLst>
+    <a:ext uri="{05A4C25C-085E-4340-85A3-A5531E510DB2}">
+      <thm15:themeFamily xmlns:thm15="http://schemas.microsoft.com/office/thememl/2012/main" name="Office Theme" id="{2E142A2C-CD16-42D6-873A-C26D2A0506FA}" vid="{1BDDFF52-6CD6-40A5-AB3C-68EB2F1E4D0A}"/>
+    </a:ext>
+  </a:extLst>
+</a:theme>
 </file>
</xml_diff>